<commit_message>
In five sentences (+1) : relecture de l'anglais appliquée
Faux ami delay remplacé (a time from now), libellé MIND MAP, chronologie
cohérente entre les tâches 2 et 3 (le plombier n'est pas venu avant 8.15),
sources vérifiables de la leçon (badge record, CCTV), the insurer plutôt
que Legal, chute de la tâche 1 et notes précisées (at ≠ by, for = depuis).

Co-Authored-By: Claude Opus 5.5 <noreply@anthropic.com>
Claude-Session: https://claude.ai/code/session_01GHo9GbchfMk8JhTz1kwo92
</commit_message>
<xml_diff>
--- a/anglais_productions/powerpoints/UE3_Lesson1_In_five_sentences.pptx
+++ b/anglais_productions/powerpoints/UE3_Lesson1_In_five_sentences.pptx
@@ -120,14 +120,14 @@
   <p:extLst>
     <p:ext uri="{521415D9-36F7-43E2-AB2F-B90AF26B5E84}">
       <p14:sectionLst xmlns:p14="http://schemas.microsoft.com/office/powerpoint/2010/main">
-        <p14:section name="How it works" id="{274fda04-980b-f0b3-db6f-cc32ce98e8ef}">
+        <p14:section name="How it works" id="{41ce8ad7-dde0-9a02-e6ed-e9dea1a393df}">
           <p14:sldIdLst>
             <p14:sldId id="257"/>
             <p14:sldId id="258"/>
             <p14:sldId id="259"/>
           </p14:sldIdLst>
         </p14:section>
-        <p14:section name="Three tasks" id="{c96502c0-53cd-a93b-4eaf-1d552d7d8097}">
+        <p14:section name="Three tasks" id="{4cbc24c7-4ccd-61df-719f-0a456e5cdd2f}">
           <p14:sldIdLst>
             <p14:sldId id="260"/>
             <p14:sldId id="261"/>
@@ -140,7 +140,7 @@
             <p14:sldId id="268"/>
           </p14:sldIdLst>
         </p14:section>
-        <p14:section name="Before you hand in" id="{77d1f233-8178-d3b8-c8d4-d637b4a81193}">
+        <p14:section name="Before you hand in" id="{be4190b3-c307-73e3-74f3-a9437fdb68da}">
           <p14:sldIdLst>
             <p14:sldId id="269"/>
           </p14:sldIdLst>
@@ -639,7 +639,7 @@
             <a:r>
               <a:rPr lang="en-US" dirty="0"/>
               <a:t>Objectif : Production 2 · Atlas House, 8 h 15 (livret p. 3–7 · role play) : écrire ou dire 5 phrases à l’oral en respectant les 5 consignes, puis, au choix, une 6e plus difficile.
-Production orale en binôme : B joue Mark et relance (« Who found it? », « Are you sure? », « How do you know? »). Attendus : between … and … ; Did + sujet + base verbale (✗ Did the guard heard) ; turn up et call out conjugués (turned up, called out ; avec un pronom : call him out). In = dans (un délai), for = pendant (une durée). Until = jusqu’à (ça continue) ≠ by = au plus tard. Le support du cours écrit tantôt 11.40, tantôt 11.41 (23 h 41) : acceptez les deux. ★ Challenge : la comparaison « Please mind the differences ». Le résultat visible maintenant (has damaged) ≠ le fait daté (found at 6.50) ; ✗ The cleaners have found the leak at 6.50.
+Production orale en binôme : B joue Mark et relance (« Who found it? », « Are you sure? », « How do you know? »). Attendus : between … and … ; Did + sujet + base verbale (✗ Did the guard heard) ; turn up et call out conjugués (turned up, called out ; avec un pronom : call him out). In = dans (un moment à venir : in twenty minutes ; attention, delay = retard), for = pendant (une durée) ; avec le present perfect, for = depuis (✗ since two hours). Until = jusqu’à (ça continue) ≠ by = au plus tard. Le support du cours écrit tantôt 11.40, tantôt 11.41 (23 h 40 ou 23 h 41) : acceptez les deux. ★ Challenge : la comparaison « Please mind the differences ». Le résultat visible maintenant (has damaged) ≠ le fait daté (found at 6.50) ; ✗ The cleaners have found the leak at 6.50.
 EXEMPLE — chaque étiquette verte renvoie à une consigne (Sentence 1 à Sentence 5) ; le cadre doré est le jalon ★ Challenge (Sentence 6). Faites retrouver, pour chaque bribe, la consigne à laquelle elle répond.</a:t>
             </a:r>
             <a:endParaRPr lang="en-US" dirty="0"/>
@@ -729,7 +729,7 @@
             <a:r>
               <a:rPr lang="en-US" dirty="0"/>
               <a:t>Objectif : Production 3 · Une chronologie pour 9 h (livret p. 4–7) : écrire ou dire 5 phrases à l’écrit en respectant les 5 consignes, puis, au choix, une 6e plus difficile.
-Production écrite, 15 min, à rendre « by nine ». Attendus : une heure vérifiable et sa source (✗ around eleven, ✗ late last night : refusés par l’expert d’assurance) ; broke down, shut down (break → broke, shut → shut). Mots de la carte mentale : people (the plumber, the cleaners, the insurer, the contractor, the witness, the assessor) · evidence (the alarm log, the CCTV, the timestamp, the receipt, the statement) · paperwork (the report, the claim, the timeline, the invoice, the message). Négation et question : didn’t + base, Did + sujet + base. Look into est inséparable (look into it) ; sort out est séparable (sort it out). ★ Challenge : un temps révolu (last November, two days ago, in 2019) appelle le past simple ; une expérience jusqu’à maintenant (never, ever) appelle le present perfect.</a:t>
+Production écrite, 15 min, à rendre « by nine ». Attendus : une heure vérifiable et sa source (✗ around eleven, ✗ late last night : refusés par l’expert d’assurance) ; broke down, shut down (break → broke, shut → shut). Mots de la carte mentale : people (the plumber, the cleaners, the insurer, the contractor, the witness, the assessor) · evidence (the voicemail, the alarm log, the CCTV, the timestamp, the receipt, the statement) · paperwork (the report, the claim, the timeline, the invoice, the message). Négation et question : didn’t + base, Did + sujet + base. Look into est inséparable (look into it) ; sort out est séparable (sort it out). ★ Challenge : un moment terminé et daté (last November, two days ago, in 2019) appelle le past simple ; une expérience jusqu’à maintenant (never, ever) appelle le present perfect.</a:t>
             </a:r>
             <a:endParaRPr lang="en-US" dirty="0"/>
           </a:p>
@@ -818,7 +818,7 @@
             <a:r>
               <a:rPr lang="en-US" dirty="0"/>
               <a:t>Objectif : Production 3 · Une chronologie pour 9 h (livret p. 4–7) : écrire ou dire 5 phrases à l’écrit en respectant les 5 consignes, puis, au choix, une 6e plus difficile.
-Production écrite, 15 min, à rendre « by nine ». Attendus : une heure vérifiable et sa source (✗ around eleven, ✗ late last night : refusés par l’expert d’assurance) ; broke down, shut down (break → broke, shut → shut). Mots de la carte mentale : people (the plumber, the cleaners, the insurer, the contractor, the witness, the assessor) · evidence (the alarm log, the CCTV, the timestamp, the receipt, the statement) · paperwork (the report, the claim, the timeline, the invoice, the message). Négation et question : didn’t + base, Did + sujet + base. Look into est inséparable (look into it) ; sort out est séparable (sort it out). ★ Challenge : un temps révolu (last November, two days ago, in 2019) appelle le past simple ; une expérience jusqu’à maintenant (never, ever) appelle le present perfect.
+Production écrite, 15 min, à rendre « by nine ». Attendus : une heure vérifiable et sa source (✗ around eleven, ✗ late last night : refusés par l’expert d’assurance) ; broke down, shut down (break → broke, shut → shut). Mots de la carte mentale : people (the plumber, the cleaners, the insurer, the contractor, the witness, the assessor) · evidence (the voicemail, the alarm log, the CCTV, the timestamp, the receipt, the statement) · paperwork (the report, the claim, the timeline, the invoice, the message). Négation et question : didn’t + base, Did + sujet + base. Look into est inséparable (look into it) ; sort out est séparable (sort it out). ★ Challenge : un moment terminé et daté (last November, two days ago, in 2019) appelle le past simple ; une expérience jusqu’à maintenant (never, ever) appelle le present perfect.
 GRANDE IMAGE — laissez les étudiant·es observer et décrire avant de produire : Where are we? Who can you see? What has happened? What time is it?</a:t>
             </a:r>
             <a:endParaRPr lang="en-US" dirty="0"/>
@@ -908,7 +908,7 @@
             <a:r>
               <a:rPr lang="en-US" dirty="0"/>
               <a:t>Objectif : Production 3 · Une chronologie pour 9 h (livret p. 4–7) : écrire ou dire 5 phrases à l’écrit en respectant les 5 consignes, puis, au choix, une 6e plus difficile.
-Production écrite, 15 min, à rendre « by nine ». Attendus : une heure vérifiable et sa source (✗ around eleven, ✗ late last night : refusés par l’expert d’assurance) ; broke down, shut down (break → broke, shut → shut). Mots de la carte mentale : people (the plumber, the cleaners, the insurer, the contractor, the witness, the assessor) · evidence (the alarm log, the CCTV, the timestamp, the receipt, the statement) · paperwork (the report, the claim, the timeline, the invoice, the message). Négation et question : didn’t + base, Did + sujet + base. Look into est inséparable (look into it) ; sort out est séparable (sort it out). ★ Challenge : un temps révolu (last November, two days ago, in 2019) appelle le past simple ; une expérience jusqu’à maintenant (never, ever) appelle le present perfect.
+Production écrite, 15 min, à rendre « by nine ». Attendus : une heure vérifiable et sa source (✗ around eleven, ✗ late last night : refusés par l’expert d’assurance) ; broke down, shut down (break → broke, shut → shut). Mots de la carte mentale : people (the plumber, the cleaners, the insurer, the contractor, the witness, the assessor) · evidence (the voicemail, the alarm log, the CCTV, the timestamp, the receipt, the statement) · paperwork (the report, the claim, the timeline, the invoice, the message). Négation et question : didn’t + base, Did + sujet + base. Look into est inséparable (look into it) ; sort out est séparable (sort it out). ★ Challenge : un moment terminé et daté (last November, two days ago, in 2019) appelle le past simple ; une expérience jusqu’à maintenant (never, ever) appelle le present perfect.
 EXEMPLE — chaque étiquette verte renvoie à une consigne (Sentence 1 à Sentence 5) ; le cadre doré est le jalon ★ Challenge (Sentence 6). Faites retrouver, pour chaque bribe, la consigne à laquelle elle répond.</a:t>
             </a:r>
             <a:endParaRPr lang="en-US" dirty="0"/>
@@ -1354,7 +1354,7 @@
             <a:r>
               <a:rPr lang="en-US" dirty="0"/>
               <a:t>Objectif : Production 1 · Le message de 06 h 58 (livret p. 3–4) : écrire ou dire 5 phrases à l’écrit en respectant les 5 consignes, puis, au choix, une 6e plus difficile.
-Production écrite, 10 min, juste après la prise de notes de la messagerie. Attendus : called, found, went off (le fait daté est au past simple) ; at + heure précise ; by + date limite (≠ until). Négation : didn’t + base verbale (✗ didn’t heard). Mark demande « for a quarter past eight » : acceptez « at 8.15 » comme « by 8.15 ». ★ Challenge : la phrase honnête de la p. 4 du livret. On ne devine pas la durée (✗ all night) ; on cite une source vérifiable : le journal d’alarme, des photos horodatées, le rapport d’un technicien. « how long the water has been running » reprend la correction du livret.</a:t>
+Production écrite, 10 min, juste après la prise de notes de la messagerie. Attendus : called, found, went off (le fait daté est au past simple) ; at + heure précise ; by + date limite (≠ until). Négation : didn’t + base verbale (✗ didn’t heard). Mark demande « for a quarter past eight » : « at 8.15 » est juste (l’heure du rendez-vous), mais la consigne 4 exige by + date limite. ★ Challenge : la phrase honnête de la p. 4 du livret. On ne devine pas la durée (✗ all night) ; on cite une source vérifiable : le journal d’alarme, des photos horodatées, les images de vidéosurveillance (CCTV), le relevé des badges. « how long the water has been running » reprend la correction du livret.</a:t>
             </a:r>
             <a:endParaRPr lang="en-US" dirty="0"/>
           </a:p>
@@ -1443,7 +1443,7 @@
             <a:r>
               <a:rPr lang="en-US" dirty="0"/>
               <a:t>Objectif : Production 1 · Le message de 06 h 58 (livret p. 3–4) : écrire ou dire 5 phrases à l’écrit en respectant les 5 consignes, puis, au choix, une 6e plus difficile.
-Production écrite, 10 min, juste après la prise de notes de la messagerie. Attendus : called, found, went off (le fait daté est au past simple) ; at + heure précise ; by + date limite (≠ until). Négation : didn’t + base verbale (✗ didn’t heard). Mark demande « for a quarter past eight » : acceptez « at 8.15 » comme « by 8.15 ». ★ Challenge : la phrase honnête de la p. 4 du livret. On ne devine pas la durée (✗ all night) ; on cite une source vérifiable : le journal d’alarme, des photos horodatées, le rapport d’un technicien. « how long the water has been running » reprend la correction du livret.
+Production écrite, 10 min, juste après la prise de notes de la messagerie. Attendus : called, found, went off (le fait daté est au past simple) ; at + heure précise ; by + date limite (≠ until). Négation : didn’t + base verbale (✗ didn’t heard). Mark demande « for a quarter past eight » : « at 8.15 » est juste (l’heure du rendez-vous), mais la consigne 4 exige by + date limite. ★ Challenge : la phrase honnête de la p. 4 du livret. On ne devine pas la durée (✗ all night) ; on cite une source vérifiable : le journal d’alarme, des photos horodatées, les images de vidéosurveillance (CCTV), le relevé des badges. « how long the water has been running » reprend la correction du livret.
 GRANDE IMAGE — laissez les étudiant·es observer et décrire avant de produire : Where are we? Who can you see? What has happened? What time is it?</a:t>
             </a:r>
             <a:endParaRPr lang="en-US" dirty="0"/>
@@ -1533,7 +1533,7 @@
             <a:r>
               <a:rPr lang="en-US" dirty="0"/>
               <a:t>Objectif : Production 1 · Le message de 06 h 58 (livret p. 3–4) : écrire ou dire 5 phrases à l’écrit en respectant les 5 consignes, puis, au choix, une 6e plus difficile.
-Production écrite, 10 min, juste après la prise de notes de la messagerie. Attendus : called, found, went off (le fait daté est au past simple) ; at + heure précise ; by + date limite (≠ until). Négation : didn’t + base verbale (✗ didn’t heard). Mark demande « for a quarter past eight » : acceptez « at 8.15 » comme « by 8.15 ». ★ Challenge : la phrase honnête de la p. 4 du livret. On ne devine pas la durée (✗ all night) ; on cite une source vérifiable : le journal d’alarme, des photos horodatées, le rapport d’un technicien. « how long the water has been running » reprend la correction du livret.
+Production écrite, 10 min, juste après la prise de notes de la messagerie. Attendus : called, found, went off (le fait daté est au past simple) ; at + heure précise ; by + date limite (≠ until). Négation : didn’t + base verbale (✗ didn’t heard). Mark demande « for a quarter past eight » : « at 8.15 » est juste (l’heure du rendez-vous), mais la consigne 4 exige by + date limite. ★ Challenge : la phrase honnête de la p. 4 du livret. On ne devine pas la durée (✗ all night) ; on cite une source vérifiable : le journal d’alarme, des photos horodatées, les images de vidéosurveillance (CCTV), le relevé des badges. « how long the water has been running » reprend la correction du livret.
 EXEMPLE — chaque étiquette verte renvoie à une consigne (Sentence 1 à Sentence 5) ; le cadre doré est le jalon ★ Challenge (Sentence 6). Faites retrouver, pour chaque bribe, la consigne à laquelle elle répond.</a:t>
             </a:r>
             <a:endParaRPr lang="en-US" dirty="0"/>
@@ -1623,7 +1623,7 @@
             <a:r>
               <a:rPr lang="en-US" dirty="0"/>
               <a:t>Objectif : Production 2 · Atlas House, 8 h 15 (livret p. 3–7 · role play) : écrire ou dire 5 phrases à l’oral en respectant les 5 consignes, puis, au choix, une 6e plus difficile.
-Production orale en binôme : B joue Mark et relance (« Who found it? », « Are you sure? », « How do you know? »). Attendus : between … and … ; Did + sujet + base verbale (✗ Did the guard heard) ; turn up et call out conjugués (turned up, called out ; avec un pronom : call him out). In = dans (un délai), for = pendant (une durée). Until = jusqu’à (ça continue) ≠ by = au plus tard. Le support du cours écrit tantôt 11.40, tantôt 11.41 (23 h 41) : acceptez les deux. ★ Challenge : la comparaison « Please mind the differences ». Le résultat visible maintenant (has damaged) ≠ le fait daté (found at 6.50) ; ✗ The cleaners have found the leak at 6.50.</a:t>
+Production orale en binôme : B joue Mark et relance (« Who found it? », « Are you sure? », « How do you know? »). Attendus : between … and … ; Did + sujet + base verbale (✗ Did the guard heard) ; turn up et call out conjugués (turned up, called out ; avec un pronom : call him out). In = dans (un moment à venir : in twenty minutes ; attention, delay = retard), for = pendant (une durée) ; avec le present perfect, for = depuis (✗ since two hours). Until = jusqu’à (ça continue) ≠ by = au plus tard. Le support du cours écrit tantôt 11.40, tantôt 11.41 (23 h 40 ou 23 h 41) : acceptez les deux. ★ Challenge : la comparaison « Please mind the differences ». Le résultat visible maintenant (has damaged) ≠ le fait daté (found at 6.50) ; ✗ The cleaners have found the leak at 6.50.</a:t>
             </a:r>
             <a:endParaRPr lang="en-US" dirty="0"/>
           </a:p>
@@ -1712,7 +1712,7 @@
             <a:r>
               <a:rPr lang="en-US" dirty="0"/>
               <a:t>Objectif : Production 2 · Atlas House, 8 h 15 (livret p. 3–7 · role play) : écrire ou dire 5 phrases à l’oral en respectant les 5 consignes, puis, au choix, une 6e plus difficile.
-Production orale en binôme : B joue Mark et relance (« Who found it? », « Are you sure? », « How do you know? »). Attendus : between … and … ; Did + sujet + base verbale (✗ Did the guard heard) ; turn up et call out conjugués (turned up, called out ; avec un pronom : call him out). In = dans (un délai), for = pendant (une durée). Until = jusqu’à (ça continue) ≠ by = au plus tard. Le support du cours écrit tantôt 11.40, tantôt 11.41 (23 h 41) : acceptez les deux. ★ Challenge : la comparaison « Please mind the differences ». Le résultat visible maintenant (has damaged) ≠ le fait daté (found at 6.50) ; ✗ The cleaners have found the leak at 6.50.
+Production orale en binôme : B joue Mark et relance (« Who found it? », « Are you sure? », « How do you know? »). Attendus : between … and … ; Did + sujet + base verbale (✗ Did the guard heard) ; turn up et call out conjugués (turned up, called out ; avec un pronom : call him out). In = dans (un moment à venir : in twenty minutes ; attention, delay = retard), for = pendant (une durée) ; avec le present perfect, for = depuis (✗ since two hours). Until = jusqu’à (ça continue) ≠ by = au plus tard. Le support du cours écrit tantôt 11.40, tantôt 11.41 (23 h 40 ou 23 h 41) : acceptez les deux. ★ Challenge : la comparaison « Please mind the differences ». Le résultat visible maintenant (has damaged) ≠ le fait daté (found at 6.50) ; ✗ The cleaners have found the leak at 6.50.
 GRANDE IMAGE — laissez les étudiant·es observer et décrire avant de produire : Where are we? Who can you see? What has happened? What time is it?</a:t>
             </a:r>
             <a:endParaRPr lang="en-US" dirty="0"/>
@@ -3974,7 +3974,7 @@
         <p:spPr>
           <a:xfrm>
             <a:off x="1691640" y="1971243"/>
-            <a:ext cx="3034919" cy="340868"/>
+            <a:ext cx="2893263" cy="340868"/>
           </a:xfrm>
           <a:prstGeom prst="roundRect">
             <a:avLst>
@@ -4003,7 +4003,7 @@
         <p:spPr>
           <a:xfrm>
             <a:off x="1691640" y="1960067"/>
-            <a:ext cx="3034919" cy="363220"/>
+            <a:ext cx="2893263" cy="363220"/>
           </a:xfrm>
           <a:prstGeom prst="rect">
             <a:avLst/>
@@ -4027,7 +4027,7 @@
                 <a:ea typeface="Calibri" pitchFamily="34" charset="-122"/>
                 <a:cs typeface="Calibri" pitchFamily="34" charset="-120"/>
               </a:rPr>
-              <a:t>Between 23.41 and 06.47</a:t>
+              <a:t>Between 23.41 and 6.47</a:t>
             </a:r>
             <a:endParaRPr lang="en-US" sz="2200" dirty="0"/>
           </a:p>
@@ -4041,8 +4041,8 @@
         </p:nvSpPr>
         <p:spPr>
           <a:xfrm>
-            <a:off x="4726559" y="1960067"/>
-            <a:ext cx="4546067" cy="363220"/>
+            <a:off x="4584903" y="1960067"/>
+            <a:ext cx="6795745" cy="363220"/>
           </a:xfrm>
           <a:prstGeom prst="rect">
             <a:avLst/>
@@ -4066,7 +4066,7 @@
                 <a:ea typeface="Calibri" pitchFamily="34" charset="-122"/>
                 <a:cs typeface="Calibri" pitchFamily="34" charset="-120"/>
               </a:rPr>
-              <a:t>, nobody checked the technical room.</a:t>
+              <a:t>, nobody went into the technical room: the badge record</a:t>
             </a:r>
             <a:endParaRPr lang="en-US" sz="2200" dirty="0"/>
           </a:p>
@@ -4080,7 +4080,137 @@
         </p:nvSpPr>
         <p:spPr>
           <a:xfrm>
-            <a:off x="9171178" y="1971243"/>
+            <a:off x="3138272" y="1896059"/>
+            <a:ext cx="914" cy="75184"/>
+          </a:xfrm>
+          <a:prstGeom prst="line">
+            <a:avLst/>
+          </a:prstGeom>
+          <a:noFill/>
+          <a:ln w="15875">
+            <a:solidFill>
+              <a:srgbClr val="7AB648"/>
+            </a:solidFill>
+            <a:prstDash val="solid"/>
+          </a:ln>
+        </p:spPr>
+      </p:sp>
+      <p:sp>
+        <p:nvSpPr>
+          <p:cNvPr id="12" name="Shape 8"/>
+          <p:cNvSpPr/>
+          <p:nvPr/>
+        </p:nvSpPr>
+        <p:spPr>
+          <a:xfrm>
+            <a:off x="2529605" y="1649171"/>
+            <a:ext cx="1217333" cy="246888"/>
+          </a:xfrm>
+          <a:prstGeom prst="roundRect">
+            <a:avLst>
+              <a:gd name="adj" fmla="val 14815"/>
+            </a:avLst>
+          </a:prstGeom>
+          <a:solidFill>
+            <a:srgbClr val="7AB648"/>
+          </a:solidFill>
+          <a:ln w="12700">
+            <a:solidFill>
+              <a:srgbClr val="FFFFFF">
+                <a:alpha val="0"/>
+              </a:srgbClr>
+            </a:solidFill>
+            <a:prstDash val="solid"/>
+          </a:ln>
+        </p:spPr>
+      </p:sp>
+      <p:sp>
+        <p:nvSpPr>
+          <p:cNvPr id="13" name="Text 9"/>
+          <p:cNvSpPr txBox="1"/>
+          <p:nvPr/>
+        </p:nvSpPr>
+        <p:spPr>
+          <a:xfrm>
+            <a:off x="2529605" y="1649171"/>
+            <a:ext cx="1217333" cy="246888"/>
+          </a:xfrm>
+          <a:prstGeom prst="rect">
+            <a:avLst/>
+          </a:prstGeom>
+          <a:noFill/>
+          <a:ln/>
+        </p:spPr>
+        <p:txBody>
+          <a:bodyPr wrap="none" lIns="0" tIns="0" rIns="0" bIns="0" rtlCol="0" anchor="ctr"/>
+          <a:lstStyle/>
+          <a:p>
+            <a:pPr algn="ctr" indent="0" marL="0">
+              <a:buNone/>
+            </a:pPr>
+            <a:r>
+              <a:rPr lang="en-US" sz="1100" dirty="0">
+                <a:solidFill>
+                  <a:srgbClr val="FFFFFF"/>
+                </a:solidFill>
+                <a:latin typeface="Calibri" pitchFamily="34" charset="0"/>
+                <a:ea typeface="Calibri" pitchFamily="34" charset="-122"/>
+                <a:cs typeface="Calibri" pitchFamily="34" charset="-120"/>
+              </a:rPr>
+              <a:t>BETWEEN … AND</a:t>
+            </a:r>
+            <a:endParaRPr lang="en-US" sz="1100" dirty="0"/>
+          </a:p>
+        </p:txBody>
+      </p:sp>
+      <p:sp>
+        <p:nvSpPr>
+          <p:cNvPr id="14" name="Text 10"/>
+          <p:cNvSpPr txBox="1"/>
+          <p:nvPr/>
+        </p:nvSpPr>
+        <p:spPr>
+          <a:xfrm>
+            <a:off x="1691640" y="2780487"/>
+            <a:ext cx="1204773" cy="363220"/>
+          </a:xfrm>
+          <a:prstGeom prst="rect">
+            <a:avLst/>
+          </a:prstGeom>
+          <a:noFill/>
+          <a:ln/>
+        </p:spPr>
+        <p:txBody>
+          <a:bodyPr wrap="none" lIns="0" tIns="0" rIns="0" bIns="0" rtlCol="0" anchor="ctr"/>
+          <a:lstStyle/>
+          <a:p>
+            <a:pPr algn="l" indent="0" marL="0">
+              <a:buNone/>
+            </a:pPr>
+            <a:r>
+              <a:rPr lang="en-US" sz="2200" dirty="0">
+                <a:solidFill>
+                  <a:srgbClr val="2B2F38"/>
+                </a:solidFill>
+                <a:latin typeface="Calibri" pitchFamily="34" charset="0"/>
+                <a:ea typeface="Calibri" pitchFamily="34" charset="-122"/>
+                <a:cs typeface="Calibri" pitchFamily="34" charset="-120"/>
+              </a:rPr>
+              <a:t>shows it.</a:t>
+            </a:r>
+            <a:endParaRPr lang="en-US" sz="2200" dirty="0"/>
+          </a:p>
+        </p:txBody>
+      </p:sp>
+      <p:sp>
+        <p:nvSpPr>
+          <p:cNvPr id="15" name="Shape 11"/>
+          <p:cNvSpPr/>
+          <p:nvPr/>
+        </p:nvSpPr>
+        <p:spPr>
+          <a:xfrm>
+            <a:off x="2794965" y="2791663"/>
             <a:ext cx="2260702" cy="340868"/>
           </a:xfrm>
           <a:prstGeom prst="roundRect">
@@ -4103,13 +4233,13 @@
       </p:sp>
       <p:sp>
         <p:nvSpPr>
-          <p:cNvPr id="12" name="Text 8"/>
-          <p:cNvSpPr txBox="1"/>
-          <p:nvPr/>
-        </p:nvSpPr>
-        <p:spPr>
-          <a:xfrm>
-            <a:off x="9171178" y="1960067"/>
+          <p:cNvPr id="16" name="Text 12"/>
+          <p:cNvSpPr txBox="1"/>
+          <p:nvPr/>
+        </p:nvSpPr>
+        <p:spPr>
+          <a:xfrm>
+            <a:off x="2794965" y="2780487"/>
             <a:ext cx="2260702" cy="363220"/>
           </a:xfrm>
           <a:prstGeom prst="rect">
@@ -4142,13 +4272,159 @@
       </p:sp>
       <p:sp>
         <p:nvSpPr>
-          <p:cNvPr id="13" name="Shape 9"/>
-          <p:cNvSpPr/>
-          <p:nvPr/>
-        </p:nvSpPr>
-        <p:spPr>
-          <a:xfrm>
-            <a:off x="3209100" y="1896059"/>
+          <p:cNvPr id="17" name="Text 13"/>
+          <p:cNvSpPr txBox="1"/>
+          <p:nvPr/>
+        </p:nvSpPr>
+        <p:spPr>
+          <a:xfrm>
+            <a:off x="5137099" y="2780487"/>
+            <a:ext cx="4870577" cy="363220"/>
+          </a:xfrm>
+          <a:prstGeom prst="rect">
+            <a:avLst/>
+          </a:prstGeom>
+          <a:noFill/>
+          <a:ln/>
+        </p:spPr>
+        <p:txBody>
+          <a:bodyPr wrap="none" lIns="0" tIns="0" rIns="0" bIns="0" rtlCol="0" anchor="ctr"/>
+          <a:lstStyle/>
+          <a:p>
+            <a:pPr algn="l" indent="0" marL="0">
+              <a:buNone/>
+            </a:pPr>
+            <a:r>
+              <a:rPr lang="en-US" sz="2200" dirty="0">
+                <a:solidFill>
+                  <a:srgbClr val="2B2F38"/>
+                </a:solidFill>
+                <a:latin typeface="Calibri" pitchFamily="34" charset="0"/>
+                <a:ea typeface="Calibri" pitchFamily="34" charset="-122"/>
+                <a:cs typeface="Calibri" pitchFamily="34" charset="-120"/>
+              </a:rPr>
+              <a:t>the alarm last night? The plumber didn’t</a:t>
+            </a:r>
+            <a:endParaRPr lang="en-US" sz="2200" dirty="0"/>
+          </a:p>
+        </p:txBody>
+      </p:sp>
+      <p:sp>
+        <p:nvSpPr>
+          <p:cNvPr id="18" name="Shape 14"/>
+          <p:cNvSpPr/>
+          <p:nvPr/>
+        </p:nvSpPr>
+        <p:spPr>
+          <a:xfrm>
+            <a:off x="9906229" y="2791663"/>
+            <a:ext cx="950874" cy="340868"/>
+          </a:xfrm>
+          <a:prstGeom prst="roundRect">
+            <a:avLst>
+              <a:gd name="adj" fmla="val 13413"/>
+            </a:avLst>
+          </a:prstGeom>
+          <a:solidFill>
+            <a:srgbClr val="E6F3DA"/>
+          </a:solidFill>
+          <a:ln w="12700">
+            <a:solidFill>
+              <a:srgbClr val="FFFFFF">
+                <a:alpha val="0"/>
+              </a:srgbClr>
+            </a:solidFill>
+            <a:prstDash val="solid"/>
+          </a:ln>
+        </p:spPr>
+      </p:sp>
+      <p:sp>
+        <p:nvSpPr>
+          <p:cNvPr id="19" name="Text 15"/>
+          <p:cNvSpPr txBox="1"/>
+          <p:nvPr/>
+        </p:nvSpPr>
+        <p:spPr>
+          <a:xfrm>
+            <a:off x="9906229" y="2780487"/>
+            <a:ext cx="950874" cy="363220"/>
+          </a:xfrm>
+          <a:prstGeom prst="rect">
+            <a:avLst/>
+          </a:prstGeom>
+          <a:noFill/>
+          <a:ln/>
+        </p:spPr>
+        <p:txBody>
+          <a:bodyPr wrap="none" lIns="0" tIns="0" rIns="0" bIns="0" rtlCol="0" anchor="ctr"/>
+          <a:lstStyle/>
+          <a:p>
+            <a:pPr algn="ctr" indent="0" marL="0">
+              <a:buNone/>
+            </a:pPr>
+            <a:r>
+              <a:rPr lang="en-US" sz="2200" b="1" dirty="0">
+                <a:solidFill>
+                  <a:srgbClr val="2B2F38"/>
+                </a:solidFill>
+                <a:latin typeface="Calibri" pitchFamily="34" charset="0"/>
+                <a:ea typeface="Calibri" pitchFamily="34" charset="-122"/>
+                <a:cs typeface="Calibri" pitchFamily="34" charset="-120"/>
+              </a:rPr>
+              <a:t>turn up</a:t>
+            </a:r>
+            <a:endParaRPr lang="en-US" sz="2200" dirty="0"/>
+          </a:p>
+        </p:txBody>
+      </p:sp>
+      <p:sp>
+        <p:nvSpPr>
+          <p:cNvPr id="20" name="Text 16"/>
+          <p:cNvSpPr txBox="1"/>
+          <p:nvPr/>
+        </p:nvSpPr>
+        <p:spPr>
+          <a:xfrm>
+            <a:off x="10857103" y="2780487"/>
+            <a:ext cx="742493" cy="363220"/>
+          </a:xfrm>
+          <a:prstGeom prst="rect">
+            <a:avLst/>
+          </a:prstGeom>
+          <a:noFill/>
+          <a:ln/>
+        </p:spPr>
+        <p:txBody>
+          <a:bodyPr wrap="none" lIns="0" tIns="0" rIns="0" bIns="0" rtlCol="0" anchor="ctr"/>
+          <a:lstStyle/>
+          <a:p>
+            <a:pPr algn="l" indent="0" marL="0">
+              <a:buNone/>
+            </a:pPr>
+            <a:r>
+              <a:rPr lang="en-US" sz="2200" dirty="0">
+                <a:solidFill>
+                  <a:srgbClr val="2B2F38"/>
+                </a:solidFill>
+                <a:latin typeface="Calibri" pitchFamily="34" charset="0"/>
+                <a:ea typeface="Calibri" pitchFamily="34" charset="-122"/>
+                <a:cs typeface="Calibri" pitchFamily="34" charset="-120"/>
+              </a:rPr>
+              <a:t>, so I</a:t>
+            </a:r>
+            <a:endParaRPr lang="en-US" sz="2200" dirty="0"/>
+          </a:p>
+        </p:txBody>
+      </p:sp>
+      <p:sp>
+        <p:nvSpPr>
+          <p:cNvPr id="21" name="Shape 17"/>
+          <p:cNvSpPr/>
+          <p:nvPr/>
+        </p:nvSpPr>
+        <p:spPr>
+          <a:xfrm>
+            <a:off x="3925316" y="2716479"/>
             <a:ext cx="914" cy="75184"/>
           </a:xfrm>
           <a:prstGeom prst="line">
@@ -4165,14 +4441,14 @@
       </p:sp>
       <p:sp>
         <p:nvSpPr>
-          <p:cNvPr id="14" name="Shape 10"/>
-          <p:cNvSpPr/>
-          <p:nvPr/>
-        </p:nvSpPr>
-        <p:spPr>
-          <a:xfrm>
-            <a:off x="2600433" y="1649171"/>
-            <a:ext cx="1217333" cy="246888"/>
+          <p:cNvPr id="22" name="Shape 18"/>
+          <p:cNvSpPr/>
+          <p:nvPr/>
+        </p:nvSpPr>
+        <p:spPr>
+          <a:xfrm>
+            <a:off x="3595351" y="2469591"/>
+            <a:ext cx="659930" cy="246888"/>
           </a:xfrm>
           <a:prstGeom prst="roundRect">
             <a:avLst>
@@ -4194,14 +4470,14 @@
       </p:sp>
       <p:sp>
         <p:nvSpPr>
-          <p:cNvPr id="15" name="Text 11"/>
-          <p:cNvSpPr txBox="1"/>
-          <p:nvPr/>
-        </p:nvSpPr>
-        <p:spPr>
-          <a:xfrm>
-            <a:off x="2600433" y="1649171"/>
-            <a:ext cx="1217333" cy="246888"/>
+          <p:cNvPr id="23" name="Text 19"/>
+          <p:cNvSpPr txBox="1"/>
+          <p:nvPr/>
+        </p:nvSpPr>
+        <p:spPr>
+          <a:xfrm>
+            <a:off x="3595351" y="2469591"/>
+            <a:ext cx="659930" cy="246888"/>
           </a:xfrm>
           <a:prstGeom prst="rect">
             <a:avLst/>
@@ -4225,7 +4501,7 @@
                 <a:ea typeface="Calibri" pitchFamily="34" charset="-122"/>
                 <a:cs typeface="Calibri" pitchFamily="34" charset="-120"/>
               </a:rPr>
-              <a:t>BETWEEN … AND</a:t>
+              <a:t>DID … ?</a:t>
             </a:r>
             <a:endParaRPr lang="en-US" sz="1100" dirty="0"/>
           </a:p>
@@ -4233,13 +4509,13 @@
       </p:sp>
       <p:sp>
         <p:nvSpPr>
-          <p:cNvPr id="16" name="Shape 12"/>
-          <p:cNvSpPr/>
-          <p:nvPr/>
-        </p:nvSpPr>
-        <p:spPr>
-          <a:xfrm>
-            <a:off x="10301529" y="1896059"/>
+          <p:cNvPr id="24" name="Shape 20"/>
+          <p:cNvSpPr/>
+          <p:nvPr/>
+        </p:nvSpPr>
+        <p:spPr>
+          <a:xfrm>
+            <a:off x="10381666" y="2716479"/>
             <a:ext cx="914" cy="75184"/>
           </a:xfrm>
           <a:prstGeom prst="line">
@@ -4256,14 +4532,14 @@
       </p:sp>
       <p:sp>
         <p:nvSpPr>
-          <p:cNvPr id="17" name="Shape 13"/>
-          <p:cNvSpPr/>
-          <p:nvPr/>
-        </p:nvSpPr>
-        <p:spPr>
-          <a:xfrm>
-            <a:off x="9971564" y="1649171"/>
-            <a:ext cx="659930" cy="246888"/>
+          <p:cNvPr id="25" name="Shape 21"/>
+          <p:cNvSpPr/>
+          <p:nvPr/>
+        </p:nvSpPr>
+        <p:spPr>
+          <a:xfrm>
+            <a:off x="9834467" y="2469591"/>
+            <a:ext cx="1094397" cy="246888"/>
           </a:xfrm>
           <a:prstGeom prst="roundRect">
             <a:avLst>
@@ -4285,14 +4561,14 @@
       </p:sp>
       <p:sp>
         <p:nvSpPr>
-          <p:cNvPr id="18" name="Text 14"/>
-          <p:cNvSpPr txBox="1"/>
-          <p:nvPr/>
-        </p:nvSpPr>
-        <p:spPr>
-          <a:xfrm>
-            <a:off x="9971564" y="1649171"/>
-            <a:ext cx="659930" cy="246888"/>
+          <p:cNvPr id="26" name="Text 22"/>
+          <p:cNvSpPr txBox="1"/>
+          <p:nvPr/>
+        </p:nvSpPr>
+        <p:spPr>
+          <a:xfrm>
+            <a:off x="9834467" y="2469591"/>
+            <a:ext cx="1094397" cy="246888"/>
           </a:xfrm>
           <a:prstGeom prst="rect">
             <a:avLst/>
@@ -4316,7 +4592,7 @@
                 <a:ea typeface="Calibri" pitchFamily="34" charset="-122"/>
                 <a:cs typeface="Calibri" pitchFamily="34" charset="-120"/>
               </a:rPr>
-              <a:t>DID … ?</a:t>
+              <a:t>PHRASAL VERB</a:t>
             </a:r>
             <a:endParaRPr lang="en-US" sz="1100" dirty="0"/>
           </a:p>
@@ -4324,53 +4600,14 @@
       </p:sp>
       <p:sp>
         <p:nvSpPr>
-          <p:cNvPr id="19" name="Text 15"/>
-          <p:cNvSpPr txBox="1"/>
-          <p:nvPr/>
-        </p:nvSpPr>
-        <p:spPr>
-          <a:xfrm>
-            <a:off x="1691640" y="2780487"/>
-            <a:ext cx="4870577" cy="363220"/>
-          </a:xfrm>
-          <a:prstGeom prst="rect">
-            <a:avLst/>
-          </a:prstGeom>
-          <a:noFill/>
-          <a:ln/>
-        </p:spPr>
-        <p:txBody>
-          <a:bodyPr wrap="none" lIns="0" tIns="0" rIns="0" bIns="0" rtlCol="0" anchor="ctr"/>
-          <a:lstStyle/>
-          <a:p>
-            <a:pPr algn="l" indent="0" marL="0">
-              <a:buNone/>
-            </a:pPr>
-            <a:r>
-              <a:rPr lang="en-US" sz="2200" dirty="0">
-                <a:solidFill>
-                  <a:srgbClr val="2B2F38"/>
-                </a:solidFill>
-                <a:latin typeface="Calibri" pitchFamily="34" charset="0"/>
-                <a:ea typeface="Calibri" pitchFamily="34" charset="-122"/>
-                <a:cs typeface="Calibri" pitchFamily="34" charset="-120"/>
-              </a:rPr>
-              <a:t>the alarm last night? The plumber didn’t</a:t>
-            </a:r>
-            <a:endParaRPr lang="en-US" sz="2200" dirty="0"/>
-          </a:p>
-        </p:txBody>
-      </p:sp>
-      <p:sp>
-        <p:nvSpPr>
-          <p:cNvPr id="20" name="Shape 16"/>
-          <p:cNvSpPr/>
-          <p:nvPr/>
-        </p:nvSpPr>
-        <p:spPr>
-          <a:xfrm>
-            <a:off x="6460769" y="2791663"/>
-            <a:ext cx="950874" cy="340868"/>
+          <p:cNvPr id="27" name="Shape 23"/>
+          <p:cNvSpPr/>
+          <p:nvPr/>
+        </p:nvSpPr>
+        <p:spPr>
+          <a:xfrm>
+            <a:off x="1691640" y="3612083"/>
+            <a:ext cx="1234745" cy="340868"/>
           </a:xfrm>
           <a:prstGeom prst="roundRect">
             <a:avLst>
@@ -4392,14 +4629,14 @@
       </p:sp>
       <p:sp>
         <p:nvSpPr>
-          <p:cNvPr id="21" name="Text 17"/>
-          <p:cNvSpPr txBox="1"/>
-          <p:nvPr/>
-        </p:nvSpPr>
-        <p:spPr>
-          <a:xfrm>
-            <a:off x="6460769" y="2780487"/>
-            <a:ext cx="950874" cy="363220"/>
+          <p:cNvPr id="28" name="Text 24"/>
+          <p:cNvSpPr txBox="1"/>
+          <p:nvPr/>
+        </p:nvSpPr>
+        <p:spPr>
+          <a:xfrm>
+            <a:off x="1691640" y="3600907"/>
+            <a:ext cx="1234745" cy="363220"/>
           </a:xfrm>
           <a:prstGeom prst="rect">
             <a:avLst/>
@@ -4423,7 +4660,7 @@
                 <a:ea typeface="Calibri" pitchFamily="34" charset="-122"/>
                 <a:cs typeface="Calibri" pitchFamily="34" charset="-120"/>
               </a:rPr>
-              <a:t>turn up</a:t>
+              <a:t>called out</a:t>
             </a:r>
             <a:endParaRPr lang="en-US" sz="2200" dirty="0"/>
           </a:p>
@@ -4431,14 +4668,14 @@
       </p:sp>
       <p:sp>
         <p:nvSpPr>
-          <p:cNvPr id="22" name="Text 18"/>
-          <p:cNvSpPr txBox="1"/>
-          <p:nvPr/>
-        </p:nvSpPr>
-        <p:spPr>
-          <a:xfrm>
-            <a:off x="7411644" y="2780487"/>
-            <a:ext cx="742493" cy="363220"/>
+          <p:cNvPr id="29" name="Text 25"/>
+          <p:cNvSpPr txBox="1"/>
+          <p:nvPr/>
+        </p:nvSpPr>
+        <p:spPr>
+          <a:xfrm>
+            <a:off x="3007817" y="3600907"/>
+            <a:ext cx="3236671" cy="363220"/>
           </a:xfrm>
           <a:prstGeom prst="rect">
             <a:avLst/>
@@ -4462,7 +4699,7 @@
                 <a:ea typeface="Calibri" pitchFamily="34" charset="-122"/>
                 <a:cs typeface="Calibri" pitchFamily="34" charset="-120"/>
               </a:rPr>
-              <a:t>, so I</a:t>
+              <a:t>another one. He’ll be here</a:t>
             </a:r>
             <a:endParaRPr lang="en-US" sz="2200" dirty="0"/>
           </a:p>
@@ -4470,14 +4707,14 @@
       </p:sp>
       <p:sp>
         <p:nvSpPr>
-          <p:cNvPr id="23" name="Shape 19"/>
-          <p:cNvSpPr/>
-          <p:nvPr/>
-        </p:nvSpPr>
-        <p:spPr>
-          <a:xfrm>
-            <a:off x="8052689" y="2791663"/>
-            <a:ext cx="1234745" cy="340868"/>
+          <p:cNvPr id="30" name="Shape 26"/>
+          <p:cNvSpPr/>
+          <p:nvPr/>
+        </p:nvSpPr>
+        <p:spPr>
+          <a:xfrm>
+            <a:off x="6143041" y="3612083"/>
+            <a:ext cx="2206498" cy="340868"/>
           </a:xfrm>
           <a:prstGeom prst="roundRect">
             <a:avLst>
@@ -4499,14 +4736,14 @@
       </p:sp>
       <p:sp>
         <p:nvSpPr>
-          <p:cNvPr id="24" name="Text 20"/>
-          <p:cNvSpPr txBox="1"/>
-          <p:nvPr/>
-        </p:nvSpPr>
-        <p:spPr>
-          <a:xfrm>
-            <a:off x="8052689" y="2780487"/>
-            <a:ext cx="1234745" cy="363220"/>
+          <p:cNvPr id="31" name="Text 27"/>
+          <p:cNvSpPr txBox="1"/>
+          <p:nvPr/>
+        </p:nvSpPr>
+        <p:spPr>
+          <a:xfrm>
+            <a:off x="6143041" y="3600907"/>
+            <a:ext cx="2206498" cy="363220"/>
           </a:xfrm>
           <a:prstGeom prst="rect">
             <a:avLst/>
@@ -4530,7 +4767,7 @@
                 <a:ea typeface="Calibri" pitchFamily="34" charset="-122"/>
                 <a:cs typeface="Calibri" pitchFamily="34" charset="-120"/>
               </a:rPr>
-              <a:t>called out</a:t>
+              <a:t>in twenty minutes</a:t>
             </a:r>
             <a:endParaRPr lang="en-US" sz="2200" dirty="0"/>
           </a:p>
@@ -4538,14 +4775,14 @@
       </p:sp>
       <p:sp>
         <p:nvSpPr>
-          <p:cNvPr id="25" name="Text 21"/>
-          <p:cNvSpPr txBox="1"/>
-          <p:nvPr/>
-        </p:nvSpPr>
-        <p:spPr>
-          <a:xfrm>
-            <a:off x="9368866" y="2780487"/>
-            <a:ext cx="2067128" cy="363220"/>
+          <p:cNvPr id="32" name="Text 28"/>
+          <p:cNvSpPr txBox="1"/>
+          <p:nvPr/>
+        </p:nvSpPr>
+        <p:spPr>
+          <a:xfrm>
+            <a:off x="8349539" y="3600907"/>
+            <a:ext cx="253289" cy="363220"/>
           </a:xfrm>
           <a:prstGeom prst="rect">
             <a:avLst/>
@@ -4569,7 +4806,7 @@
                 <a:ea typeface="Calibri" pitchFamily="34" charset="-122"/>
                 <a:cs typeface="Calibri" pitchFamily="34" charset="-120"/>
               </a:rPr>
-              <a:t>another one. He</a:t>
+              <a:t>.</a:t>
             </a:r>
             <a:endParaRPr lang="en-US" sz="2200" dirty="0"/>
           </a:p>
@@ -4577,13 +4814,13 @@
       </p:sp>
       <p:sp>
         <p:nvSpPr>
-          <p:cNvPr id="26" name="Shape 22"/>
-          <p:cNvSpPr/>
-          <p:nvPr/>
-        </p:nvSpPr>
-        <p:spPr>
-          <a:xfrm>
-            <a:off x="6936207" y="2716479"/>
+          <p:cNvPr id="33" name="Shape 29"/>
+          <p:cNvSpPr/>
+          <p:nvPr/>
+        </p:nvSpPr>
+        <p:spPr>
+          <a:xfrm>
+            <a:off x="2309012" y="3536899"/>
             <a:ext cx="914" cy="75184"/>
           </a:xfrm>
           <a:prstGeom prst="line">
@@ -4600,13 +4837,13 @@
       </p:sp>
       <p:sp>
         <p:nvSpPr>
-          <p:cNvPr id="27" name="Shape 23"/>
-          <p:cNvSpPr/>
-          <p:nvPr/>
-        </p:nvSpPr>
-        <p:spPr>
-          <a:xfrm>
-            <a:off x="6389008" y="2469591"/>
+          <p:cNvPr id="34" name="Shape 30"/>
+          <p:cNvSpPr/>
+          <p:nvPr/>
+        </p:nvSpPr>
+        <p:spPr>
+          <a:xfrm>
+            <a:off x="1761814" y="3290011"/>
             <a:ext cx="1094397" cy="246888"/>
           </a:xfrm>
           <a:prstGeom prst="roundRect">
@@ -4629,13 +4866,13 @@
       </p:sp>
       <p:sp>
         <p:nvSpPr>
-          <p:cNvPr id="28" name="Text 24"/>
-          <p:cNvSpPr txBox="1"/>
-          <p:nvPr/>
-        </p:nvSpPr>
-        <p:spPr>
-          <a:xfrm>
-            <a:off x="6389008" y="2469591"/>
+          <p:cNvPr id="35" name="Text 31"/>
+          <p:cNvSpPr txBox="1"/>
+          <p:nvPr/>
+        </p:nvSpPr>
+        <p:spPr>
+          <a:xfrm>
+            <a:off x="1761814" y="3290011"/>
             <a:ext cx="1094397" cy="246888"/>
           </a:xfrm>
           <a:prstGeom prst="rect">
@@ -4668,13 +4905,13 @@
       </p:sp>
       <p:sp>
         <p:nvSpPr>
-          <p:cNvPr id="29" name="Shape 25"/>
-          <p:cNvSpPr/>
-          <p:nvPr/>
-        </p:nvSpPr>
-        <p:spPr>
-          <a:xfrm>
-            <a:off x="8670061" y="2716479"/>
+          <p:cNvPr id="36" name="Shape 32"/>
+          <p:cNvSpPr/>
+          <p:nvPr/>
+        </p:nvSpPr>
+        <p:spPr>
+          <a:xfrm>
+            <a:off x="7246290" y="3536899"/>
             <a:ext cx="914" cy="75184"/>
           </a:xfrm>
           <a:prstGeom prst="line">
@@ -4691,14 +4928,14 @@
       </p:sp>
       <p:sp>
         <p:nvSpPr>
-          <p:cNvPr id="30" name="Shape 26"/>
-          <p:cNvSpPr/>
-          <p:nvPr/>
-        </p:nvSpPr>
-        <p:spPr>
-          <a:xfrm>
-            <a:off x="8122863" y="2469591"/>
-            <a:ext cx="1094397" cy="246888"/>
+          <p:cNvPr id="37" name="Shape 33"/>
+          <p:cNvSpPr/>
+          <p:nvPr/>
+        </p:nvSpPr>
+        <p:spPr>
+          <a:xfrm>
+            <a:off x="6891668" y="3290011"/>
+            <a:ext cx="709244" cy="246888"/>
           </a:xfrm>
           <a:prstGeom prst="roundRect">
             <a:avLst>
@@ -4720,14 +4957,14 @@
       </p:sp>
       <p:sp>
         <p:nvSpPr>
-          <p:cNvPr id="31" name="Text 27"/>
-          <p:cNvSpPr txBox="1"/>
-          <p:nvPr/>
-        </p:nvSpPr>
-        <p:spPr>
-          <a:xfrm>
-            <a:off x="8122863" y="2469591"/>
-            <a:ext cx="1094397" cy="246888"/>
+          <p:cNvPr id="38" name="Text 34"/>
+          <p:cNvSpPr txBox="1"/>
+          <p:nvPr/>
+        </p:nvSpPr>
+        <p:spPr>
+          <a:xfrm>
+            <a:off x="6891668" y="3290011"/>
+            <a:ext cx="709244" cy="246888"/>
           </a:xfrm>
           <a:prstGeom prst="rect">
             <a:avLst/>
@@ -4751,7 +4988,7 @@
                 <a:ea typeface="Calibri" pitchFamily="34" charset="-122"/>
                 <a:cs typeface="Calibri" pitchFamily="34" charset="-120"/>
               </a:rPr>
-              <a:t>PHRASAL VERB</a:t>
+              <a:t>IN / FOR</a:t>
             </a:r>
             <a:endParaRPr lang="en-US" sz="1100" dirty="0"/>
           </a:p>
@@ -4759,14 +4996,14 @@
       </p:sp>
       <p:sp>
         <p:nvSpPr>
-          <p:cNvPr id="32" name="Text 28"/>
-          <p:cNvSpPr txBox="1"/>
-          <p:nvPr/>
-        </p:nvSpPr>
-        <p:spPr>
-          <a:xfrm>
-            <a:off x="1691640" y="3600907"/>
-            <a:ext cx="1546606" cy="363220"/>
+          <p:cNvPr id="39" name="Text 35"/>
+          <p:cNvSpPr txBox="1"/>
+          <p:nvPr/>
+        </p:nvSpPr>
+        <p:spPr>
+          <a:xfrm>
+            <a:off x="2496007" y="4622495"/>
+            <a:ext cx="3558667" cy="363220"/>
           </a:xfrm>
           <a:prstGeom prst="rect">
             <a:avLst/>
@@ -4790,7 +5027,7 @@
                 <a:ea typeface="Calibri" pitchFamily="34" charset="-122"/>
                 <a:cs typeface="Calibri" pitchFamily="34" charset="-120"/>
               </a:rPr>
-              <a:t>will be here</a:t>
+              <a:t>We can’t put the timeline off</a:t>
             </a:r>
             <a:endParaRPr lang="en-US" sz="2200" dirty="0"/>
           </a:p>
@@ -4798,14 +5035,14 @@
       </p:sp>
       <p:sp>
         <p:nvSpPr>
-          <p:cNvPr id="33" name="Shape 29"/>
-          <p:cNvSpPr/>
-          <p:nvPr/>
-        </p:nvSpPr>
-        <p:spPr>
-          <a:xfrm>
-            <a:off x="3136798" y="3612083"/>
-            <a:ext cx="2206498" cy="340868"/>
+          <p:cNvPr id="40" name="Shape 36"/>
+          <p:cNvSpPr/>
+          <p:nvPr/>
+        </p:nvSpPr>
+        <p:spPr>
+          <a:xfrm>
+            <a:off x="5953227" y="4633671"/>
+            <a:ext cx="1405738" cy="340868"/>
           </a:xfrm>
           <a:prstGeom prst="roundRect">
             <a:avLst>
@@ -4827,14 +5064,14 @@
       </p:sp>
       <p:sp>
         <p:nvSpPr>
-          <p:cNvPr id="34" name="Text 30"/>
-          <p:cNvSpPr txBox="1"/>
-          <p:nvPr/>
-        </p:nvSpPr>
-        <p:spPr>
-          <a:xfrm>
-            <a:off x="3136798" y="3600907"/>
-            <a:ext cx="2206498" cy="363220"/>
+          <p:cNvPr id="41" name="Text 37"/>
+          <p:cNvSpPr txBox="1"/>
+          <p:nvPr/>
+        </p:nvSpPr>
+        <p:spPr>
+          <a:xfrm>
+            <a:off x="5953227" y="4622495"/>
+            <a:ext cx="1405738" cy="363220"/>
           </a:xfrm>
           <a:prstGeom prst="rect">
             <a:avLst/>
@@ -4858,7 +5095,7 @@
                 <a:ea typeface="Calibri" pitchFamily="34" charset="-122"/>
                 <a:cs typeface="Calibri" pitchFamily="34" charset="-120"/>
               </a:rPr>
-              <a:t>in twenty minutes</a:t>
+              <a:t>until Friday</a:t>
             </a:r>
             <a:endParaRPr lang="en-US" sz="2200" dirty="0"/>
           </a:p>
@@ -4866,14 +5103,14 @@
       </p:sp>
       <p:sp>
         <p:nvSpPr>
-          <p:cNvPr id="35" name="Text 31"/>
-          <p:cNvSpPr txBox="1"/>
-          <p:nvPr/>
-        </p:nvSpPr>
-        <p:spPr>
-          <a:xfrm>
-            <a:off x="5343296" y="3600907"/>
-            <a:ext cx="253289" cy="363220"/>
+          <p:cNvPr id="42" name="Text 38"/>
+          <p:cNvSpPr txBox="1"/>
+          <p:nvPr/>
+        </p:nvSpPr>
+        <p:spPr>
+          <a:xfrm>
+            <a:off x="7358964" y="4622495"/>
+            <a:ext cx="2604948" cy="363220"/>
           </a:xfrm>
           <a:prstGeom prst="rect">
             <a:avLst/>
@@ -4897,7 +5134,7 @@
                 <a:ea typeface="Calibri" pitchFamily="34" charset="-122"/>
                 <a:cs typeface="Calibri" pitchFamily="34" charset="-120"/>
               </a:rPr>
-              <a:t>.</a:t>
+              <a:t>: the insurer wants it</a:t>
             </a:r>
             <a:endParaRPr lang="en-US" sz="2200" dirty="0"/>
           </a:p>
@@ -4905,13 +5142,120 @@
       </p:sp>
       <p:sp>
         <p:nvSpPr>
-          <p:cNvPr id="36" name="Shape 32"/>
-          <p:cNvSpPr/>
-          <p:nvPr/>
-        </p:nvSpPr>
-        <p:spPr>
-          <a:xfrm>
-            <a:off x="4240047" y="3536899"/>
+          <p:cNvPr id="43" name="Shape 39"/>
+          <p:cNvSpPr/>
+          <p:nvPr/>
+        </p:nvSpPr>
+        <p:spPr>
+          <a:xfrm>
+            <a:off x="9862464" y="4633671"/>
+            <a:ext cx="946404" cy="340868"/>
+          </a:xfrm>
+          <a:prstGeom prst="roundRect">
+            <a:avLst>
+              <a:gd name="adj" fmla="val 13413"/>
+            </a:avLst>
+          </a:prstGeom>
+          <a:solidFill>
+            <a:srgbClr val="E6F3DA"/>
+          </a:solidFill>
+          <a:ln w="12700">
+            <a:solidFill>
+              <a:srgbClr val="FFFFFF">
+                <a:alpha val="0"/>
+              </a:srgbClr>
+            </a:solidFill>
+            <a:prstDash val="solid"/>
+          </a:ln>
+        </p:spPr>
+      </p:sp>
+      <p:sp>
+        <p:nvSpPr>
+          <p:cNvPr id="44" name="Text 40"/>
+          <p:cNvSpPr txBox="1"/>
+          <p:nvPr/>
+        </p:nvSpPr>
+        <p:spPr>
+          <a:xfrm>
+            <a:off x="9862464" y="4622495"/>
+            <a:ext cx="946404" cy="363220"/>
+          </a:xfrm>
+          <a:prstGeom prst="rect">
+            <a:avLst/>
+          </a:prstGeom>
+          <a:noFill/>
+          <a:ln/>
+        </p:spPr>
+        <p:txBody>
+          <a:bodyPr wrap="none" lIns="0" tIns="0" rIns="0" bIns="0" rtlCol="0" anchor="ctr"/>
+          <a:lstStyle/>
+          <a:p>
+            <a:pPr algn="ctr" indent="0" marL="0">
+              <a:buNone/>
+            </a:pPr>
+            <a:r>
+              <a:rPr lang="en-US" sz="2200" b="1" dirty="0">
+                <a:solidFill>
+                  <a:srgbClr val="2B2F38"/>
+                </a:solidFill>
+                <a:latin typeface="Calibri" pitchFamily="34" charset="0"/>
+                <a:ea typeface="Calibri" pitchFamily="34" charset="-122"/>
+                <a:cs typeface="Calibri" pitchFamily="34" charset="-120"/>
+              </a:rPr>
+              <a:t>by nine</a:t>
+            </a:r>
+            <a:endParaRPr lang="en-US" sz="2200" dirty="0"/>
+          </a:p>
+        </p:txBody>
+      </p:sp>
+      <p:sp>
+        <p:nvSpPr>
+          <p:cNvPr id="45" name="Text 41"/>
+          <p:cNvSpPr txBox="1"/>
+          <p:nvPr/>
+        </p:nvSpPr>
+        <p:spPr>
+          <a:xfrm>
+            <a:off x="10808868" y="4622495"/>
+            <a:ext cx="273964" cy="363220"/>
+          </a:xfrm>
+          <a:prstGeom prst="rect">
+            <a:avLst/>
+          </a:prstGeom>
+          <a:noFill/>
+          <a:ln/>
+        </p:spPr>
+        <p:txBody>
+          <a:bodyPr wrap="none" lIns="0" tIns="0" rIns="0" bIns="0" rtlCol="0" anchor="ctr"/>
+          <a:lstStyle/>
+          <a:p>
+            <a:pPr algn="l" indent="0" marL="0">
+              <a:buNone/>
+            </a:pPr>
+            <a:r>
+              <a:rPr lang="en-US" sz="2200" dirty="0">
+                <a:solidFill>
+                  <a:srgbClr val="2B2F38"/>
+                </a:solidFill>
+                <a:latin typeface="Calibri" pitchFamily="34" charset="0"/>
+                <a:ea typeface="Calibri" pitchFamily="34" charset="-122"/>
+                <a:cs typeface="Calibri" pitchFamily="34" charset="-120"/>
+              </a:rPr>
+              <a:t>!</a:t>
+            </a:r>
+            <a:endParaRPr lang="en-US" sz="2200" dirty="0"/>
+          </a:p>
+        </p:txBody>
+      </p:sp>
+      <p:sp>
+        <p:nvSpPr>
+          <p:cNvPr id="46" name="Shape 42"/>
+          <p:cNvSpPr/>
+          <p:nvPr/>
+        </p:nvSpPr>
+        <p:spPr>
+          <a:xfrm>
+            <a:off x="6656095" y="4558487"/>
             <a:ext cx="914" cy="75184"/>
           </a:xfrm>
           <a:prstGeom prst="line">
@@ -4928,14 +5272,14 @@
       </p:sp>
       <p:sp>
         <p:nvSpPr>
-          <p:cNvPr id="37" name="Shape 33"/>
-          <p:cNvSpPr/>
-          <p:nvPr/>
-        </p:nvSpPr>
-        <p:spPr>
-          <a:xfrm>
-            <a:off x="3885425" y="3290011"/>
-            <a:ext cx="709244" cy="246888"/>
+          <p:cNvPr id="47" name="Shape 43"/>
+          <p:cNvSpPr/>
+          <p:nvPr/>
+        </p:nvSpPr>
+        <p:spPr>
+          <a:xfrm>
+            <a:off x="6371952" y="4311599"/>
+            <a:ext cx="568287" cy="246888"/>
           </a:xfrm>
           <a:prstGeom prst="roundRect">
             <a:avLst>
@@ -4957,14 +5301,14 @@
       </p:sp>
       <p:sp>
         <p:nvSpPr>
-          <p:cNvPr id="38" name="Text 34"/>
-          <p:cNvSpPr txBox="1"/>
-          <p:nvPr/>
-        </p:nvSpPr>
-        <p:spPr>
-          <a:xfrm>
-            <a:off x="3885425" y="3290011"/>
-            <a:ext cx="709244" cy="246888"/>
+          <p:cNvPr id="48" name="Text 44"/>
+          <p:cNvSpPr txBox="1"/>
+          <p:nvPr/>
+        </p:nvSpPr>
+        <p:spPr>
+          <a:xfrm>
+            <a:off x="6371952" y="4311599"/>
+            <a:ext cx="568287" cy="246888"/>
           </a:xfrm>
           <a:prstGeom prst="rect">
             <a:avLst/>
@@ -4988,7 +5332,7 @@
                 <a:ea typeface="Calibri" pitchFamily="34" charset="-122"/>
                 <a:cs typeface="Calibri" pitchFamily="34" charset="-120"/>
               </a:rPr>
-              <a:t>IN / FOR</a:t>
+              <a:t>UNTIL</a:t>
             </a:r>
             <a:endParaRPr lang="en-US" sz="1100" dirty="0"/>
           </a:p>
@@ -4996,266 +5340,13 @@
       </p:sp>
       <p:sp>
         <p:nvSpPr>
-          <p:cNvPr id="39" name="Text 35"/>
-          <p:cNvSpPr txBox="1"/>
-          <p:nvPr/>
-        </p:nvSpPr>
-        <p:spPr>
-          <a:xfrm>
-            <a:off x="2828696" y="4622495"/>
-            <a:ext cx="2577008" cy="363220"/>
-          </a:xfrm>
-          <a:prstGeom prst="rect">
-            <a:avLst/>
-          </a:prstGeom>
-          <a:noFill/>
-          <a:ln/>
-        </p:spPr>
-        <p:txBody>
-          <a:bodyPr wrap="none" lIns="0" tIns="0" rIns="0" bIns="0" rtlCol="0" anchor="ctr"/>
-          <a:lstStyle/>
-          <a:p>
-            <a:pPr algn="l" indent="0" marL="0">
-              <a:buNone/>
-            </a:pPr>
-            <a:r>
-              <a:rPr lang="en-US" sz="2200" dirty="0">
-                <a:solidFill>
-                  <a:srgbClr val="2B2F38"/>
-                </a:solidFill>
-                <a:latin typeface="Calibri" pitchFamily="34" charset="0"/>
-                <a:ea typeface="Calibri" pitchFamily="34" charset="-122"/>
-                <a:cs typeface="Calibri" pitchFamily="34" charset="-120"/>
-              </a:rPr>
-              <a:t>We can’t put this off</a:t>
-            </a:r>
-            <a:endParaRPr lang="en-US" sz="2200" dirty="0"/>
-          </a:p>
-        </p:txBody>
-      </p:sp>
-      <p:sp>
-        <p:nvSpPr>
-          <p:cNvPr id="40" name="Shape 36"/>
-          <p:cNvSpPr/>
-          <p:nvPr/>
-        </p:nvSpPr>
-        <p:spPr>
-          <a:xfrm>
-            <a:off x="5304257" y="4633671"/>
-            <a:ext cx="1405738" cy="340868"/>
-          </a:xfrm>
-          <a:prstGeom prst="roundRect">
-            <a:avLst>
-              <a:gd name="adj" fmla="val 13413"/>
-            </a:avLst>
-          </a:prstGeom>
-          <a:solidFill>
-            <a:srgbClr val="E6F3DA"/>
-          </a:solidFill>
-          <a:ln w="12700">
-            <a:solidFill>
-              <a:srgbClr val="FFFFFF">
-                <a:alpha val="0"/>
-              </a:srgbClr>
-            </a:solidFill>
-            <a:prstDash val="solid"/>
-          </a:ln>
-        </p:spPr>
-      </p:sp>
-      <p:sp>
-        <p:nvSpPr>
-          <p:cNvPr id="41" name="Text 37"/>
-          <p:cNvSpPr txBox="1"/>
-          <p:nvPr/>
-        </p:nvSpPr>
-        <p:spPr>
-          <a:xfrm>
-            <a:off x="5304257" y="4622495"/>
-            <a:ext cx="1405738" cy="363220"/>
-          </a:xfrm>
-          <a:prstGeom prst="rect">
-            <a:avLst/>
-          </a:prstGeom>
-          <a:noFill/>
-          <a:ln/>
-        </p:spPr>
-        <p:txBody>
-          <a:bodyPr wrap="none" lIns="0" tIns="0" rIns="0" bIns="0" rtlCol="0" anchor="ctr"/>
-          <a:lstStyle/>
-          <a:p>
-            <a:pPr algn="ctr" indent="0" marL="0">
-              <a:buNone/>
-            </a:pPr>
-            <a:r>
-              <a:rPr lang="en-US" sz="2200" b="1" dirty="0">
-                <a:solidFill>
-                  <a:srgbClr val="2B2F38"/>
-                </a:solidFill>
-                <a:latin typeface="Calibri" pitchFamily="34" charset="0"/>
-                <a:ea typeface="Calibri" pitchFamily="34" charset="-122"/>
-                <a:cs typeface="Calibri" pitchFamily="34" charset="-120"/>
-              </a:rPr>
-              <a:t>until Friday</a:t>
-            </a:r>
-            <a:endParaRPr lang="en-US" sz="2200" dirty="0"/>
-          </a:p>
-        </p:txBody>
-      </p:sp>
-      <p:sp>
-        <p:nvSpPr>
-          <p:cNvPr id="42" name="Text 38"/>
-          <p:cNvSpPr txBox="1"/>
-          <p:nvPr/>
-        </p:nvSpPr>
-        <p:spPr>
-          <a:xfrm>
-            <a:off x="6709994" y="4622495"/>
-            <a:ext cx="2921229" cy="363220"/>
-          </a:xfrm>
-          <a:prstGeom prst="rect">
-            <a:avLst/>
-          </a:prstGeom>
-          <a:noFill/>
-          <a:ln/>
-        </p:spPr>
-        <p:txBody>
-          <a:bodyPr wrap="none" lIns="0" tIns="0" rIns="0" bIns="0" rtlCol="0" anchor="ctr"/>
-          <a:lstStyle/>
-          <a:p>
-            <a:pPr algn="l" indent="0" marL="0">
-              <a:buNone/>
-            </a:pPr>
-            <a:r>
-              <a:rPr lang="en-US" sz="2200" dirty="0">
-                <a:solidFill>
-                  <a:srgbClr val="2B2F38"/>
-                </a:solidFill>
-                <a:latin typeface="Calibri" pitchFamily="34" charset="0"/>
-                <a:ea typeface="Calibri" pitchFamily="34" charset="-122"/>
-                <a:cs typeface="Calibri" pitchFamily="34" charset="-120"/>
-              </a:rPr>
-              <a:t>: Legal wants a timeline</a:t>
-            </a:r>
-            <a:endParaRPr lang="en-US" sz="2200" dirty="0"/>
-          </a:p>
-        </p:txBody>
-      </p:sp>
-      <p:sp>
-        <p:nvSpPr>
-          <p:cNvPr id="43" name="Shape 39"/>
-          <p:cNvSpPr/>
-          <p:nvPr/>
-        </p:nvSpPr>
-        <p:spPr>
-          <a:xfrm>
-            <a:off x="9529775" y="4633671"/>
-            <a:ext cx="946404" cy="340868"/>
-          </a:xfrm>
-          <a:prstGeom prst="roundRect">
-            <a:avLst>
-              <a:gd name="adj" fmla="val 13413"/>
-            </a:avLst>
-          </a:prstGeom>
-          <a:solidFill>
-            <a:srgbClr val="E6F3DA"/>
-          </a:solidFill>
-          <a:ln w="12700">
-            <a:solidFill>
-              <a:srgbClr val="FFFFFF">
-                <a:alpha val="0"/>
-              </a:srgbClr>
-            </a:solidFill>
-            <a:prstDash val="solid"/>
-          </a:ln>
-        </p:spPr>
-      </p:sp>
-      <p:sp>
-        <p:nvSpPr>
-          <p:cNvPr id="44" name="Text 40"/>
-          <p:cNvSpPr txBox="1"/>
-          <p:nvPr/>
-        </p:nvSpPr>
-        <p:spPr>
-          <a:xfrm>
-            <a:off x="9529775" y="4622495"/>
-            <a:ext cx="946404" cy="363220"/>
-          </a:xfrm>
-          <a:prstGeom prst="rect">
-            <a:avLst/>
-          </a:prstGeom>
-          <a:noFill/>
-          <a:ln/>
-        </p:spPr>
-        <p:txBody>
-          <a:bodyPr wrap="none" lIns="0" tIns="0" rIns="0" bIns="0" rtlCol="0" anchor="ctr"/>
-          <a:lstStyle/>
-          <a:p>
-            <a:pPr algn="ctr" indent="0" marL="0">
-              <a:buNone/>
-            </a:pPr>
-            <a:r>
-              <a:rPr lang="en-US" sz="2200" b="1" dirty="0">
-                <a:solidFill>
-                  <a:srgbClr val="2B2F38"/>
-                </a:solidFill>
-                <a:latin typeface="Calibri" pitchFamily="34" charset="0"/>
-                <a:ea typeface="Calibri" pitchFamily="34" charset="-122"/>
-                <a:cs typeface="Calibri" pitchFamily="34" charset="-120"/>
-              </a:rPr>
-              <a:t>by nine</a:t>
-            </a:r>
-            <a:endParaRPr lang="en-US" sz="2200" dirty="0"/>
-          </a:p>
-        </p:txBody>
-      </p:sp>
-      <p:sp>
-        <p:nvSpPr>
-          <p:cNvPr id="45" name="Text 41"/>
-          <p:cNvSpPr txBox="1"/>
-          <p:nvPr/>
-        </p:nvSpPr>
-        <p:spPr>
-          <a:xfrm>
-            <a:off x="10476179" y="4622495"/>
-            <a:ext cx="273964" cy="363220"/>
-          </a:xfrm>
-          <a:prstGeom prst="rect">
-            <a:avLst/>
-          </a:prstGeom>
-          <a:noFill/>
-          <a:ln/>
-        </p:spPr>
-        <p:txBody>
-          <a:bodyPr wrap="none" lIns="0" tIns="0" rIns="0" bIns="0" rtlCol="0" anchor="ctr"/>
-          <a:lstStyle/>
-          <a:p>
-            <a:pPr algn="l" indent="0" marL="0">
-              <a:buNone/>
-            </a:pPr>
-            <a:r>
-              <a:rPr lang="en-US" sz="2200" dirty="0">
-                <a:solidFill>
-                  <a:srgbClr val="2B2F38"/>
-                </a:solidFill>
-                <a:latin typeface="Calibri" pitchFamily="34" charset="0"/>
-                <a:ea typeface="Calibri" pitchFamily="34" charset="-122"/>
-                <a:cs typeface="Calibri" pitchFamily="34" charset="-120"/>
-              </a:rPr>
-              <a:t>!</a:t>
-            </a:r>
-            <a:endParaRPr lang="en-US" sz="2200" dirty="0"/>
-          </a:p>
-        </p:txBody>
-      </p:sp>
-      <p:sp>
-        <p:nvSpPr>
-          <p:cNvPr id="46" name="Shape 42"/>
-          <p:cNvSpPr/>
-          <p:nvPr/>
-        </p:nvSpPr>
-        <p:spPr>
-          <a:xfrm>
-            <a:off x="6007125" y="4558487"/>
+          <p:cNvPr id="49" name="Shape 45"/>
+          <p:cNvSpPr/>
+          <p:nvPr/>
+        </p:nvSpPr>
+        <p:spPr>
+          <a:xfrm>
+            <a:off x="10335666" y="4558487"/>
             <a:ext cx="914" cy="75184"/>
           </a:xfrm>
           <a:prstGeom prst="line">
@@ -5272,14 +5363,14 @@
       </p:sp>
       <p:sp>
         <p:nvSpPr>
-          <p:cNvPr id="47" name="Shape 43"/>
-          <p:cNvSpPr/>
-          <p:nvPr/>
-        </p:nvSpPr>
-        <p:spPr>
-          <a:xfrm>
-            <a:off x="5722982" y="4311599"/>
-            <a:ext cx="568287" cy="246888"/>
+          <p:cNvPr id="50" name="Shape 46"/>
+          <p:cNvSpPr/>
+          <p:nvPr/>
+        </p:nvSpPr>
+        <p:spPr>
+          <a:xfrm>
+            <a:off x="10150431" y="4311599"/>
+            <a:ext cx="370472" cy="246888"/>
           </a:xfrm>
           <a:prstGeom prst="roundRect">
             <a:avLst>
@@ -5301,104 +5392,13 @@
       </p:sp>
       <p:sp>
         <p:nvSpPr>
-          <p:cNvPr id="48" name="Text 44"/>
-          <p:cNvSpPr txBox="1"/>
-          <p:nvPr/>
-        </p:nvSpPr>
-        <p:spPr>
-          <a:xfrm>
-            <a:off x="5722982" y="4311599"/>
-            <a:ext cx="568287" cy="246888"/>
-          </a:xfrm>
-          <a:prstGeom prst="rect">
-            <a:avLst/>
-          </a:prstGeom>
-          <a:noFill/>
-          <a:ln/>
-        </p:spPr>
-        <p:txBody>
-          <a:bodyPr wrap="none" lIns="0" tIns="0" rIns="0" bIns="0" rtlCol="0" anchor="ctr"/>
-          <a:lstStyle/>
-          <a:p>
-            <a:pPr algn="ctr" indent="0" marL="0">
-              <a:buNone/>
-            </a:pPr>
-            <a:r>
-              <a:rPr lang="en-US" sz="1100" dirty="0">
-                <a:solidFill>
-                  <a:srgbClr val="FFFFFF"/>
-                </a:solidFill>
-                <a:latin typeface="Calibri" pitchFamily="34" charset="0"/>
-                <a:ea typeface="Calibri" pitchFamily="34" charset="-122"/>
-                <a:cs typeface="Calibri" pitchFamily="34" charset="-120"/>
-              </a:rPr>
-              <a:t>UNTIL</a:t>
-            </a:r>
-            <a:endParaRPr lang="en-US" sz="1100" dirty="0"/>
-          </a:p>
-        </p:txBody>
-      </p:sp>
-      <p:sp>
-        <p:nvSpPr>
-          <p:cNvPr id="49" name="Shape 45"/>
-          <p:cNvSpPr/>
-          <p:nvPr/>
-        </p:nvSpPr>
-        <p:spPr>
-          <a:xfrm>
-            <a:off x="10002977" y="4558487"/>
-            <a:ext cx="914" cy="75184"/>
-          </a:xfrm>
-          <a:prstGeom prst="line">
-            <a:avLst/>
-          </a:prstGeom>
-          <a:noFill/>
-          <a:ln w="15875">
-            <a:solidFill>
-              <a:srgbClr val="7AB648"/>
-            </a:solidFill>
-            <a:prstDash val="solid"/>
-          </a:ln>
-        </p:spPr>
-      </p:sp>
-      <p:sp>
-        <p:nvSpPr>
-          <p:cNvPr id="50" name="Shape 46"/>
-          <p:cNvSpPr/>
-          <p:nvPr/>
-        </p:nvSpPr>
-        <p:spPr>
-          <a:xfrm>
-            <a:off x="9817741" y="4311599"/>
-            <a:ext cx="370472" cy="246888"/>
-          </a:xfrm>
-          <a:prstGeom prst="roundRect">
-            <a:avLst>
-              <a:gd name="adj" fmla="val 14815"/>
-            </a:avLst>
-          </a:prstGeom>
-          <a:solidFill>
-            <a:srgbClr val="7AB648"/>
-          </a:solidFill>
-          <a:ln w="12700">
-            <a:solidFill>
-              <a:srgbClr val="FFFFFF">
-                <a:alpha val="0"/>
-              </a:srgbClr>
-            </a:solidFill>
-            <a:prstDash val="solid"/>
-          </a:ln>
-        </p:spPr>
-      </p:sp>
-      <p:sp>
-        <p:nvSpPr>
           <p:cNvPr id="51" name="Text 47"/>
           <p:cNvSpPr txBox="1"/>
           <p:nvPr/>
         </p:nvSpPr>
         <p:spPr>
           <a:xfrm>
-            <a:off x="9817741" y="4311599"/>
+            <a:off x="10150431" y="4311599"/>
             <a:ext cx="370472" cy="246888"/>
           </a:xfrm>
           <a:prstGeom prst="rect">
@@ -5747,7 +5747,7 @@
         <p:spPr>
           <a:xfrm>
             <a:off x="9379077" y="5918403"/>
-            <a:ext cx="2064182" cy="363220"/>
+            <a:ext cx="2263673" cy="363220"/>
           </a:xfrm>
           <a:prstGeom prst="rect">
             <a:avLst/>
@@ -5771,7 +5771,7 @@
                 <a:ea typeface="Calibri" pitchFamily="34" charset="-122"/>
                 <a:cs typeface="Calibri" pitchFamily="34" charset="-120"/>
               </a:rPr>
-              <a:t>the leak at 6.50.</a:t>
+              <a:t>the water at 6.50.</a:t>
             </a:r>
             <a:endParaRPr lang="en-US" sz="2200" dirty="0"/>
           </a:p>
@@ -6615,7 +6615,7 @@
                   <a:srgbClr val="2B2F38"/>
                 </a:solidFill>
               </a:rPr>
-              <a:t>Two phrasal verbs from the Word file: </a:t>
+              <a:t>Two phrasal verbs from the lesson: </a:t>
             </a:r>
             <a:r>
               <a:rPr lang="en-US" sz="1450" b="1" dirty="0">
@@ -6919,7 +6919,7 @@
                   <a:srgbClr val="2B2F38"/>
                 </a:solidFill>
               </a:rPr>
-              <a:t> and a </a:t>
+              <a:t>, and a </a:t>
             </a:r>
             <a:r>
               <a:rPr lang="en-US" sz="1450" b="1" dirty="0">
@@ -6935,7 +6935,7 @@
                   <a:srgbClr val="2B2F38"/>
                 </a:solidFill>
               </a:rPr>
-              <a:t> in the past simple.</a:t>
+              <a:t> for Mark, in the past simple.</a:t>
             </a:r>
             <a:endParaRPr lang="en-US" sz="1450" dirty="0"/>
           </a:p>
@@ -9226,7 +9226,7 @@
                 <a:ea typeface="Calibri" pitchFamily="34" charset="-122"/>
                 <a:cs typeface="Calibri" pitchFamily="34" charset="-120"/>
               </a:rPr>
-              <a:t>before 7.30.</a:t>
+              <a:t>before 8.15.</a:t>
             </a:r>
             <a:endParaRPr lang="en-US" sz="1800" dirty="0"/>
           </a:p>
@@ -9712,7 +9712,7 @@
         <p:spPr>
           <a:xfrm>
             <a:off x="1691640" y="3866998"/>
-            <a:ext cx="1012698" cy="297180"/>
+            <a:ext cx="2609926" cy="297180"/>
           </a:xfrm>
           <a:prstGeom prst="rect">
             <a:avLst/>
@@ -9736,7 +9736,7 @@
                 <a:ea typeface="Calibri" pitchFamily="34" charset="-122"/>
                 <a:cs typeface="Calibri" pitchFamily="34" charset="-120"/>
               </a:rPr>
-              <a:t>him out?</a:t>
+              <a:t>him out during the night?</a:t>
             </a:r>
             <a:endParaRPr lang="en-US" sz="1800" dirty="0"/>
           </a:p>
@@ -9750,8 +9750,8 @@
         </p:nvSpPr>
         <p:spPr>
           <a:xfrm>
-            <a:off x="2846870" y="4822546"/>
-            <a:ext cx="1617802" cy="297180"/>
+            <a:off x="2677363" y="4822546"/>
+            <a:ext cx="1626946" cy="297180"/>
           </a:xfrm>
           <a:prstGeom prst="rect">
             <a:avLst/>
@@ -9775,7 +9775,7 @@
                 <a:ea typeface="Calibri" pitchFamily="34" charset="-122"/>
                 <a:cs typeface="Calibri" pitchFamily="34" charset="-120"/>
               </a:rPr>
-              <a:t>Next, Legal will</a:t>
+              <a:t>Next, Mark will</a:t>
             </a:r>
             <a:endParaRPr lang="en-US" sz="1800" dirty="0"/>
           </a:p>
@@ -9789,7 +9789,7 @@
         </p:nvSpPr>
         <p:spPr>
           <a:xfrm>
-            <a:off x="4351744" y="4831690"/>
+            <a:off x="4191381" y="4831690"/>
             <a:ext cx="936346" cy="278892"/>
           </a:xfrm>
           <a:prstGeom prst="roundRect">
@@ -9818,7 +9818,7 @@
         </p:nvSpPr>
         <p:spPr>
           <a:xfrm>
-            <a:off x="4351744" y="4822546"/>
+            <a:off x="4191381" y="4822546"/>
             <a:ext cx="936346" cy="297180"/>
           </a:xfrm>
           <a:prstGeom prst="rect">
@@ -9857,8 +9857,8 @@
         </p:nvSpPr>
         <p:spPr>
           <a:xfrm>
-            <a:off x="5358041" y="4822546"/>
-            <a:ext cx="5373929" cy="297180"/>
+            <a:off x="5197678" y="4822546"/>
+            <a:ext cx="5703799" cy="297180"/>
           </a:xfrm>
           <a:prstGeom prst="rect">
             <a:avLst/>
@@ -9882,7 +9882,7 @@
                 <a:ea typeface="Calibri" pitchFamily="34" charset="-122"/>
                 <a:cs typeface="Calibri" pitchFamily="34" charset="-120"/>
               </a:rPr>
-              <a:t>the badge log… before the insurer’s assessor turns up!</a:t>
+              <a:t>the badge record… before the insurer’s assessor turns up!</a:t>
             </a:r>
             <a:endParaRPr lang="en-US" sz="1800" dirty="0"/>
           </a:p>
@@ -9896,7 +9896,7 @@
         </p:nvSpPr>
         <p:spPr>
           <a:xfrm>
-            <a:off x="4819917" y="4758538"/>
+            <a:off x="4659554" y="4758538"/>
             <a:ext cx="914" cy="73152"/>
           </a:xfrm>
           <a:prstGeom prst="line">
@@ -9919,7 +9919,7 @@
         </p:nvSpPr>
         <p:spPr>
           <a:xfrm>
-            <a:off x="4385735" y="4511650"/>
+            <a:off x="4225373" y="4511650"/>
             <a:ext cx="868363" cy="246888"/>
           </a:xfrm>
           <a:prstGeom prst="roundRect">
@@ -9948,7 +9948,7 @@
         </p:nvSpPr>
         <p:spPr>
           <a:xfrm>
-            <a:off x="4385735" y="4511650"/>
+            <a:off x="4225373" y="4511650"/>
             <a:ext cx="868363" cy="246888"/>
           </a:xfrm>
           <a:prstGeom prst="rect">
@@ -10083,7 +10083,7 @@
         <p:spPr>
           <a:xfrm>
             <a:off x="1691640" y="6052414"/>
-            <a:ext cx="2262454" cy="297180"/>
+            <a:ext cx="2275713" cy="297180"/>
           </a:xfrm>
           <a:prstGeom prst="rect">
             <a:avLst/>
@@ -10107,7 +10107,7 @@
                 <a:ea typeface="Calibri" pitchFamily="34" charset="-122"/>
                 <a:cs typeface="Calibri" pitchFamily="34" charset="-120"/>
               </a:rPr>
-              <a:t>The same riser leaked</a:t>
+              <a:t>There was an incident</a:t>
             </a:r>
             <a:endParaRPr lang="en-US" sz="1800" dirty="0"/>
           </a:p>
@@ -10121,7 +10121,7 @@
         </p:nvSpPr>
         <p:spPr>
           <a:xfrm>
-            <a:off x="3841166" y="6061558"/>
+            <a:off x="3854425" y="6061558"/>
             <a:ext cx="1484300" cy="278892"/>
           </a:xfrm>
           <a:prstGeom prst="roundRect">
@@ -10150,7 +10150,7 @@
         </p:nvSpPr>
         <p:spPr>
           <a:xfrm>
-            <a:off x="3841166" y="6052414"/>
+            <a:off x="3854425" y="6052414"/>
             <a:ext cx="1484300" cy="297180"/>
           </a:xfrm>
           <a:prstGeom prst="rect">
@@ -10189,7 +10189,7 @@
         </p:nvSpPr>
         <p:spPr>
           <a:xfrm>
-            <a:off x="5325466" y="6052414"/>
+            <a:off x="5338724" y="6052414"/>
             <a:ext cx="1404747" cy="297180"/>
           </a:xfrm>
           <a:prstGeom prst="rect">
@@ -10228,7 +10228,7 @@
         </p:nvSpPr>
         <p:spPr>
           <a:xfrm>
-            <a:off x="6617284" y="6061558"/>
+            <a:off x="6630543" y="6061558"/>
             <a:ext cx="2070202" cy="278892"/>
           </a:xfrm>
           <a:prstGeom prst="roundRect">
@@ -10257,7 +10257,7 @@
         </p:nvSpPr>
         <p:spPr>
           <a:xfrm>
-            <a:off x="6617284" y="6052414"/>
+            <a:off x="6630543" y="6052414"/>
             <a:ext cx="2070202" cy="297180"/>
           </a:xfrm>
           <a:prstGeom prst="rect">
@@ -10296,7 +10296,7 @@
         </p:nvSpPr>
         <p:spPr>
           <a:xfrm>
-            <a:off x="8757437" y="6052414"/>
+            <a:off x="8770696" y="6052414"/>
             <a:ext cx="858164" cy="297180"/>
           </a:xfrm>
           <a:prstGeom prst="rect">
@@ -10335,7 +10335,7 @@
         </p:nvSpPr>
         <p:spPr>
           <a:xfrm>
-            <a:off x="4583316" y="5988406"/>
+            <a:off x="4596575" y="5988406"/>
             <a:ext cx="914" cy="73152"/>
           </a:xfrm>
           <a:prstGeom prst="line">
@@ -10358,7 +10358,7 @@
         </p:nvSpPr>
         <p:spPr>
           <a:xfrm>
-            <a:off x="4038841" y="5741518"/>
+            <a:off x="4052100" y="5741518"/>
             <a:ext cx="1088949" cy="246888"/>
           </a:xfrm>
           <a:prstGeom prst="roundRect">
@@ -10387,7 +10387,7 @@
         </p:nvSpPr>
         <p:spPr>
           <a:xfrm>
-            <a:off x="4038841" y="5741518"/>
+            <a:off x="4052100" y="5741518"/>
             <a:ext cx="1088949" cy="246888"/>
           </a:xfrm>
           <a:prstGeom prst="rect">
@@ -10426,7 +10426,7 @@
         </p:nvSpPr>
         <p:spPr>
           <a:xfrm>
-            <a:off x="7652385" y="5988406"/>
+            <a:off x="7665644" y="5988406"/>
             <a:ext cx="914" cy="73152"/>
           </a:xfrm>
           <a:prstGeom prst="line">
@@ -10449,7 +10449,7 @@
         </p:nvSpPr>
         <p:spPr>
           <a:xfrm>
-            <a:off x="7020319" y="5741518"/>
+            <a:off x="7033578" y="5741518"/>
             <a:ext cx="1264133" cy="246888"/>
           </a:xfrm>
           <a:prstGeom prst="roundRect">
@@ -10478,7 +10478,7 @@
         </p:nvSpPr>
         <p:spPr>
           <a:xfrm>
-            <a:off x="7020319" y="5741518"/>
+            <a:off x="7033578" y="5741518"/>
             <a:ext cx="1264133" cy="246888"/>
           </a:xfrm>
           <a:prstGeom prst="rect">
@@ -17645,7 +17645,7 @@
                   <a:srgbClr val="2B2F38"/>
                 </a:solidFill>
               </a:rPr>
-              <a:t>Where exactly? Two words for </a:t>
+              <a:t>Where exactly? Two </a:t>
             </a:r>
             <a:r>
               <a:rPr lang="en-US" sz="1450" b="1" dirty="0">
@@ -17653,7 +17653,7 @@
                   <a:srgbClr val="2B2F38"/>
                 </a:solidFill>
               </a:rPr>
-              <a:t>THE PLACE</a:t>
+              <a:t>PLACE</a:t>
             </a:r>
             <a:r>
               <a:rPr lang="en-US" sz="1450" dirty="0">
@@ -17661,7 +17661,7 @@
                   <a:srgbClr val="2B2F38"/>
                 </a:solidFill>
               </a:rPr>
-              <a:t>: the technical room, the floor…</a:t>
+              <a:t> words from the mind map: the technical room, the floor, the ceiling…</a:t>
             </a:r>
             <a:endParaRPr lang="en-US" sz="1450" dirty="0"/>
           </a:p>
@@ -18704,8 +18704,8 @@
         </p:nvSpPr>
         <p:spPr>
           <a:xfrm>
-            <a:off x="1691640" y="1993087"/>
-            <a:ext cx="1412519" cy="346710"/>
+            <a:off x="1691640" y="2092147"/>
+            <a:ext cx="1239469" cy="297180"/>
           </a:xfrm>
           <a:prstGeom prst="rect">
             <a:avLst/>
@@ -18721,7 +18721,7 @@
               <a:buNone/>
             </a:pPr>
             <a:r>
-              <a:rPr lang="en-US" sz="2100" dirty="0">
+              <a:rPr lang="en-US" sz="1800" dirty="0">
                 <a:solidFill>
                   <a:srgbClr val="2B2F38"/>
                 </a:solidFill>
@@ -18731,7 +18731,7 @@
               </a:rPr>
               <a:t>Mark Shaw</a:t>
             </a:r>
-            <a:endParaRPr lang="en-US" sz="2100" dirty="0"/>
+            <a:endParaRPr lang="en-US" sz="1800" dirty="0"/>
           </a:p>
         </p:txBody>
       </p:sp>
@@ -18743,12 +18743,12 @@
         </p:nvSpPr>
         <p:spPr>
           <a:xfrm>
-            <a:off x="2999842" y="2003755"/>
-            <a:ext cx="1564958" cy="325374"/>
+            <a:off x="2818181" y="2101291"/>
+            <a:ext cx="1354455" cy="278892"/>
           </a:xfrm>
           <a:prstGeom prst="roundRect">
             <a:avLst>
-              <a:gd name="adj" fmla="val 14052"/>
+              <a:gd name="adj" fmla="val 16393"/>
             </a:avLst>
           </a:prstGeom>
           <a:solidFill>
@@ -18772,8 +18772,8 @@
         </p:nvSpPr>
         <p:spPr>
           <a:xfrm>
-            <a:off x="2999842" y="1993087"/>
-            <a:ext cx="1564958" cy="346710"/>
+            <a:off x="2818181" y="2092147"/>
+            <a:ext cx="1354455" cy="297180"/>
           </a:xfrm>
           <a:prstGeom prst="rect">
             <a:avLst/>
@@ -18789,7 +18789,7 @@
               <a:buNone/>
             </a:pPr>
             <a:r>
-              <a:rPr lang="en-US" sz="2100" b="1" dirty="0">
+              <a:rPr lang="en-US" sz="1800" b="1" dirty="0">
                 <a:solidFill>
                   <a:srgbClr val="2B2F38"/>
                 </a:solidFill>
@@ -18799,7 +18799,7 @@
               </a:rPr>
               <a:t>called at 6.58</a:t>
             </a:r>
-            <a:endParaRPr lang="en-US" sz="2100" dirty="0"/>
+            <a:endParaRPr lang="en-US" sz="1800" dirty="0"/>
           </a:p>
         </p:txBody>
       </p:sp>
@@ -18811,8 +18811,8 @@
         </p:nvSpPr>
         <p:spPr>
           <a:xfrm>
-            <a:off x="4643361" y="1993087"/>
-            <a:ext cx="5348326" cy="346710"/>
+            <a:off x="4242587" y="2092147"/>
+            <a:ext cx="4628693" cy="297180"/>
           </a:xfrm>
           <a:prstGeom prst="rect">
             <a:avLst/>
@@ -18828,7 +18828,7 @@
               <a:buNone/>
             </a:pPr>
             <a:r>
-              <a:rPr lang="en-US" sz="2100" dirty="0">
+              <a:rPr lang="en-US" sz="1800" dirty="0">
                 <a:solidFill>
                   <a:srgbClr val="2B2F38"/>
                 </a:solidFill>
@@ -18838,7 +18838,7 @@
               </a:rPr>
               <a:t>this morning and left a voicemail. The cleaners</a:t>
             </a:r>
-            <a:endParaRPr lang="en-US" sz="2100" dirty="0"/>
+            <a:endParaRPr lang="en-US" sz="1800" dirty="0"/>
           </a:p>
         </p:txBody>
       </p:sp>
@@ -18850,12 +18850,12 @@
         </p:nvSpPr>
         <p:spPr>
           <a:xfrm>
-            <a:off x="9887369" y="2003755"/>
-            <a:ext cx="748856" cy="325374"/>
+            <a:off x="8758352" y="2101291"/>
+            <a:ext cx="654939" cy="278892"/>
           </a:xfrm>
           <a:prstGeom prst="roundRect">
             <a:avLst>
-              <a:gd name="adj" fmla="val 14052"/>
+              <a:gd name="adj" fmla="val 16393"/>
             </a:avLst>
           </a:prstGeom>
           <a:solidFill>
@@ -18879,8 +18879,8 @@
         </p:nvSpPr>
         <p:spPr>
           <a:xfrm>
-            <a:off x="9887369" y="1993087"/>
-            <a:ext cx="748856" cy="346710"/>
+            <a:off x="8758352" y="2092147"/>
+            <a:ext cx="654939" cy="297180"/>
           </a:xfrm>
           <a:prstGeom prst="rect">
             <a:avLst/>
@@ -18896,7 +18896,7 @@
               <a:buNone/>
             </a:pPr>
             <a:r>
-              <a:rPr lang="en-US" sz="2100" b="1" dirty="0">
+              <a:rPr lang="en-US" sz="1800" b="1" dirty="0">
                 <a:solidFill>
                   <a:srgbClr val="2B2F38"/>
                 </a:solidFill>
@@ -18906,7 +18906,7 @@
               </a:rPr>
               <a:t>found</a:t>
             </a:r>
-            <a:endParaRPr lang="en-US" sz="2100" dirty="0"/>
+            <a:endParaRPr lang="en-US" sz="1800" dirty="0"/>
           </a:p>
         </p:txBody>
       </p:sp>
@@ -18918,8 +18918,8 @@
         </p:nvSpPr>
         <p:spPr>
           <a:xfrm>
-            <a:off x="10714787" y="1993087"/>
-            <a:ext cx="1112215" cy="346710"/>
+            <a:off x="9483242" y="2092147"/>
+            <a:ext cx="2133067" cy="297180"/>
           </a:xfrm>
           <a:prstGeom prst="rect">
             <a:avLst/>
@@ -18935,17 +18935,17 @@
               <a:buNone/>
             </a:pPr>
             <a:r>
-              <a:rPr lang="en-US" sz="2100" dirty="0">
-                <a:solidFill>
-                  <a:srgbClr val="2B2F38"/>
-                </a:solidFill>
-                <a:latin typeface="Calibri" pitchFamily="34" charset="0"/>
-                <a:ea typeface="Calibri" pitchFamily="34" charset="-122"/>
-                <a:cs typeface="Calibri" pitchFamily="34" charset="-120"/>
-              </a:rPr>
-              <a:t>water at</a:t>
-            </a:r>
-            <a:endParaRPr lang="en-US" sz="2100" dirty="0"/>
+              <a:rPr lang="en-US" sz="1800" dirty="0">
+                <a:solidFill>
+                  <a:srgbClr val="2B2F38"/>
+                </a:solidFill>
+                <a:latin typeface="Calibri" pitchFamily="34" charset="0"/>
+                <a:ea typeface="Calibri" pitchFamily="34" charset="-122"/>
+                <a:cs typeface="Calibri" pitchFamily="34" charset="-120"/>
+              </a:rPr>
+              <a:t>water at 6.50, and it</a:t>
+            </a:r>
+            <a:endParaRPr lang="en-US" sz="1800" dirty="0"/>
           </a:p>
         </p:txBody>
       </p:sp>
@@ -18957,8 +18957,8 @@
         </p:nvSpPr>
         <p:spPr>
           <a:xfrm>
-            <a:off x="3782320" y="1929079"/>
-            <a:ext cx="914" cy="74676"/>
+            <a:off x="3495408" y="2028139"/>
+            <a:ext cx="914" cy="73152"/>
           </a:xfrm>
           <a:prstGeom prst="line">
             <a:avLst/>
@@ -18980,7 +18980,7 @@
         </p:nvSpPr>
         <p:spPr>
           <a:xfrm>
-            <a:off x="3380969" y="1682191"/>
+            <a:off x="3094057" y="1781251"/>
             <a:ext cx="802704" cy="246888"/>
           </a:xfrm>
           <a:prstGeom prst="roundRect">
@@ -19009,7 +19009,7 @@
         </p:nvSpPr>
         <p:spPr>
           <a:xfrm>
-            <a:off x="3380969" y="1682191"/>
+            <a:off x="3094057" y="1781251"/>
             <a:ext cx="802704" cy="246888"/>
           </a:xfrm>
           <a:prstGeom prst="rect">
@@ -19048,8 +19048,8 @@
         </p:nvSpPr>
         <p:spPr>
           <a:xfrm>
-            <a:off x="10261797" y="1929079"/>
-            <a:ext cx="914" cy="74676"/>
+            <a:off x="9085821" y="2028139"/>
+            <a:ext cx="914" cy="73152"/>
           </a:xfrm>
           <a:prstGeom prst="line">
             <a:avLst/>
@@ -19071,7 +19071,7 @@
         </p:nvSpPr>
         <p:spPr>
           <a:xfrm>
-            <a:off x="9819373" y="1682191"/>
+            <a:off x="8643398" y="1781251"/>
             <a:ext cx="884847" cy="246888"/>
           </a:xfrm>
           <a:prstGeom prst="roundRect">
@@ -19100,7 +19100,7 @@
         </p:nvSpPr>
         <p:spPr>
           <a:xfrm>
-            <a:off x="9819373" y="1682191"/>
+            <a:off x="8643398" y="1781251"/>
             <a:ext cx="884847" cy="246888"/>
           </a:xfrm>
           <a:prstGeom prst="rect">
@@ -19139,8 +19139,8 @@
         </p:nvSpPr>
         <p:spPr>
           <a:xfrm>
-            <a:off x="1691640" y="2796997"/>
-            <a:ext cx="5349316" cy="346710"/>
+            <a:off x="1691640" y="2846527"/>
+            <a:ext cx="3220288" cy="297180"/>
           </a:xfrm>
           <a:prstGeom prst="rect">
             <a:avLst/>
@@ -19156,17 +19156,17 @@
               <a:buNone/>
             </a:pPr>
             <a:r>
-              <a:rPr lang="en-US" sz="2100" dirty="0">
-                <a:solidFill>
-                  <a:srgbClr val="2B2F38"/>
-                </a:solidFill>
-                <a:latin typeface="Calibri" pitchFamily="34" charset="0"/>
-                <a:ea typeface="Calibri" pitchFamily="34" charset="-122"/>
-                <a:cs typeface="Calibri" pitchFamily="34" charset="-120"/>
-              </a:rPr>
-              <a:t>6.50, and it was still running. The leak is in the</a:t>
-            </a:r>
-            <a:endParaRPr lang="en-US" sz="2100" dirty="0"/>
+              <a:rPr lang="en-US" sz="1800" dirty="0">
+                <a:solidFill>
+                  <a:srgbClr val="2B2F38"/>
+                </a:solidFill>
+                <a:latin typeface="Calibri" pitchFamily="34" charset="0"/>
+                <a:ea typeface="Calibri" pitchFamily="34" charset="-122"/>
+                <a:cs typeface="Calibri" pitchFamily="34" charset="-120"/>
+              </a:rPr>
+              <a:t>was still running. There is water</a:t>
+            </a:r>
+            <a:endParaRPr lang="en-US" sz="1800" dirty="0"/>
           </a:p>
         </p:txBody>
       </p:sp>
@@ -19178,12 +19178,12 @@
         </p:nvSpPr>
         <p:spPr>
           <a:xfrm>
-            <a:off x="6936638" y="2807665"/>
-            <a:ext cx="1749247" cy="325374"/>
+            <a:off x="4799000" y="2855671"/>
+            <a:ext cx="1213180" cy="278892"/>
           </a:xfrm>
           <a:prstGeom prst="roundRect">
             <a:avLst>
-              <a:gd name="adj" fmla="val 14052"/>
+              <a:gd name="adj" fmla="val 16393"/>
             </a:avLst>
           </a:prstGeom>
           <a:solidFill>
@@ -19207,8 +19207,8 @@
         </p:nvSpPr>
         <p:spPr>
           <a:xfrm>
-            <a:off x="6936638" y="2796997"/>
-            <a:ext cx="1749247" cy="346710"/>
+            <a:off x="4799000" y="2846527"/>
+            <a:ext cx="1213180" cy="297180"/>
           </a:xfrm>
           <a:prstGeom prst="rect">
             <a:avLst/>
@@ -19224,17 +19224,17 @@
               <a:buNone/>
             </a:pPr>
             <a:r>
-              <a:rPr lang="en-US" sz="2100" b="1" dirty="0">
-                <a:solidFill>
-                  <a:srgbClr val="2B2F38"/>
-                </a:solidFill>
-                <a:latin typeface="Calibri" pitchFamily="34" charset="0"/>
-                <a:ea typeface="Calibri" pitchFamily="34" charset="-122"/>
-                <a:cs typeface="Calibri" pitchFamily="34" charset="-120"/>
-              </a:rPr>
-              <a:t>technical room</a:t>
-            </a:r>
-            <a:endParaRPr lang="en-US" sz="2100" dirty="0"/>
+              <a:rPr lang="en-US" sz="1800" b="1" dirty="0">
+                <a:solidFill>
+                  <a:srgbClr val="2B2F38"/>
+                </a:solidFill>
+                <a:latin typeface="Calibri" pitchFamily="34" charset="0"/>
+                <a:ea typeface="Calibri" pitchFamily="34" charset="-122"/>
+                <a:cs typeface="Calibri" pitchFamily="34" charset="-120"/>
+              </a:rPr>
+              <a:t>on the floor</a:t>
+            </a:r>
+            <a:endParaRPr lang="en-US" sz="1800" dirty="0"/>
           </a:p>
         </p:txBody>
       </p:sp>
@@ -19246,8 +19246,8 @@
         </p:nvSpPr>
         <p:spPr>
           <a:xfrm>
-            <a:off x="8685886" y="2796997"/>
-            <a:ext cx="1049426" cy="346710"/>
+            <a:off x="6082132" y="2846527"/>
+            <a:ext cx="753466" cy="297180"/>
           </a:xfrm>
           <a:prstGeom prst="rect">
             <a:avLst/>
@@ -19263,17 +19263,17 @@
               <a:buNone/>
             </a:pPr>
             <a:r>
-              <a:rPr lang="en-US" sz="2100" dirty="0">
-                <a:solidFill>
-                  <a:srgbClr val="2B2F38"/>
-                </a:solidFill>
-                <a:latin typeface="Calibri" pitchFamily="34" charset="0"/>
-                <a:ea typeface="Calibri" pitchFamily="34" charset="-122"/>
-                <a:cs typeface="Calibri" pitchFamily="34" charset="-120"/>
-              </a:rPr>
-              <a:t>, on the</a:t>
-            </a:r>
-            <a:endParaRPr lang="en-US" sz="2100" dirty="0"/>
+              <a:rPr lang="en-US" sz="1800" dirty="0">
+                <a:solidFill>
+                  <a:srgbClr val="2B2F38"/>
+                </a:solidFill>
+                <a:latin typeface="Calibri" pitchFamily="34" charset="0"/>
+                <a:ea typeface="Calibri" pitchFamily="34" charset="-122"/>
+                <a:cs typeface="Calibri" pitchFamily="34" charset="-120"/>
+              </a:rPr>
+              <a:t>of the</a:t>
+            </a:r>
+            <a:endParaRPr lang="en-US" sz="1800" dirty="0"/>
           </a:p>
         </p:txBody>
       </p:sp>
@@ -19285,12 +19285,12 @@
         </p:nvSpPr>
         <p:spPr>
           <a:xfrm>
-            <a:off x="9630994" y="2807665"/>
-            <a:ext cx="1465212" cy="325374"/>
+            <a:off x="6722669" y="2855671"/>
+            <a:ext cx="1512418" cy="278892"/>
           </a:xfrm>
           <a:prstGeom prst="roundRect">
             <a:avLst>
-              <a:gd name="adj" fmla="val 14052"/>
+              <a:gd name="adj" fmla="val 16393"/>
             </a:avLst>
           </a:prstGeom>
           <a:solidFill>
@@ -19314,8 +19314,8 @@
         </p:nvSpPr>
         <p:spPr>
           <a:xfrm>
-            <a:off x="9630994" y="2796997"/>
-            <a:ext cx="1465212" cy="346710"/>
+            <a:off x="6722669" y="2846527"/>
+            <a:ext cx="1512418" cy="297180"/>
           </a:xfrm>
           <a:prstGeom prst="rect">
             <a:avLst/>
@@ -19331,17 +19331,17 @@
               <a:buNone/>
             </a:pPr>
             <a:r>
-              <a:rPr lang="en-US" sz="2100" b="1" dirty="0">
-                <a:solidFill>
-                  <a:srgbClr val="2B2F38"/>
-                </a:solidFill>
-                <a:latin typeface="Calibri" pitchFamily="34" charset="0"/>
-                <a:ea typeface="Calibri" pitchFamily="34" charset="-122"/>
-                <a:cs typeface="Calibri" pitchFamily="34" charset="-120"/>
-              </a:rPr>
-              <a:t>second floor</a:t>
-            </a:r>
-            <a:endParaRPr lang="en-US" sz="2100" dirty="0"/>
+              <a:rPr lang="en-US" sz="1800" b="1" dirty="0">
+                <a:solidFill>
+                  <a:srgbClr val="2B2F38"/>
+                </a:solidFill>
+                <a:latin typeface="Calibri" pitchFamily="34" charset="0"/>
+                <a:ea typeface="Calibri" pitchFamily="34" charset="-122"/>
+                <a:cs typeface="Calibri" pitchFamily="34" charset="-120"/>
+              </a:rPr>
+              <a:t>technical room</a:t>
+            </a:r>
+            <a:endParaRPr lang="en-US" sz="1800" dirty="0"/>
           </a:p>
         </p:txBody>
       </p:sp>
@@ -19353,8 +19353,8 @@
         </p:nvSpPr>
         <p:spPr>
           <a:xfrm>
-            <a:off x="11174768" y="2796997"/>
-            <a:ext cx="404774" cy="346710"/>
+            <a:off x="8235086" y="2846527"/>
+            <a:ext cx="3449117" cy="297180"/>
           </a:xfrm>
           <a:prstGeom prst="rect">
             <a:avLst/>
@@ -19370,17 +19370,17 @@
               <a:buNone/>
             </a:pPr>
             <a:r>
-              <a:rPr lang="en-US" sz="2100" dirty="0">
-                <a:solidFill>
-                  <a:srgbClr val="2B2F38"/>
-                </a:solidFill>
-                <a:latin typeface="Calibri" pitchFamily="34" charset="0"/>
-                <a:ea typeface="Calibri" pitchFamily="34" charset="-122"/>
-                <a:cs typeface="Calibri" pitchFamily="34" charset="-120"/>
-              </a:rPr>
-              <a:t>of</a:t>
-            </a:r>
-            <a:endParaRPr lang="en-US" sz="2100" dirty="0"/>
+              <a:rPr lang="en-US" sz="1800" dirty="0">
+                <a:solidFill>
+                  <a:srgbClr val="2B2F38"/>
+                </a:solidFill>
+                <a:latin typeface="Calibri" pitchFamily="34" charset="0"/>
+                <a:ea typeface="Calibri" pitchFamily="34" charset="-122"/>
+                <a:cs typeface="Calibri" pitchFamily="34" charset="-120"/>
+              </a:rPr>
+              <a:t>, on the second floor. Please bring</a:t>
+            </a:r>
+            <a:endParaRPr lang="en-US" sz="1800" dirty="0"/>
           </a:p>
         </p:txBody>
       </p:sp>
@@ -19392,8 +19392,8 @@
         </p:nvSpPr>
         <p:spPr>
           <a:xfrm>
-            <a:off x="7811262" y="2732989"/>
-            <a:ext cx="914" cy="74676"/>
+            <a:off x="5405590" y="2782519"/>
+            <a:ext cx="914" cy="73152"/>
           </a:xfrm>
           <a:prstGeom prst="line">
             <a:avLst/>
@@ -19415,7 +19415,7 @@
         </p:nvSpPr>
         <p:spPr>
           <a:xfrm>
-            <a:off x="7392937" y="2486101"/>
+            <a:off x="4987265" y="2535631"/>
             <a:ext cx="836651" cy="246888"/>
           </a:xfrm>
           <a:prstGeom prst="roundRect">
@@ -19444,7 +19444,7 @@
         </p:nvSpPr>
         <p:spPr>
           <a:xfrm>
-            <a:off x="7392937" y="2486101"/>
+            <a:off x="4987265" y="2535631"/>
             <a:ext cx="836651" cy="246888"/>
           </a:xfrm>
           <a:prstGeom prst="rect">
@@ -19483,8 +19483,8 @@
         </p:nvSpPr>
         <p:spPr>
           <a:xfrm>
-            <a:off x="10363600" y="2732989"/>
-            <a:ext cx="914" cy="74676"/>
+            <a:off x="7478878" y="2782519"/>
+            <a:ext cx="914" cy="73152"/>
           </a:xfrm>
           <a:prstGeom prst="line">
             <a:avLst/>
@@ -19506,7 +19506,7 @@
         </p:nvSpPr>
         <p:spPr>
           <a:xfrm>
-            <a:off x="9945275" y="2486101"/>
+            <a:off x="7060552" y="2535631"/>
             <a:ext cx="836651" cy="246888"/>
           </a:xfrm>
           <a:prstGeom prst="roundRect">
@@ -19535,7 +19535,7 @@
         </p:nvSpPr>
         <p:spPr>
           <a:xfrm>
-            <a:off x="9945275" y="2486101"/>
+            <a:off x="7060552" y="2535631"/>
             <a:ext cx="836651" cy="246888"/>
           </a:xfrm>
           <a:prstGeom prst="rect">
@@ -19575,7 +19575,7 @@
         <p:spPr>
           <a:xfrm>
             <a:off x="1691640" y="3600907"/>
-            <a:ext cx="8916619" cy="346710"/>
+            <a:ext cx="4870094" cy="297180"/>
           </a:xfrm>
           <a:prstGeom prst="rect">
             <a:avLst/>
@@ -19591,17 +19591,17 @@
               <a:buNone/>
             </a:pPr>
             <a:r>
-              <a:rPr lang="en-US" sz="2100" dirty="0">
-                <a:solidFill>
-                  <a:srgbClr val="2B2F38"/>
-                </a:solidFill>
-                <a:latin typeface="Calibri" pitchFamily="34" charset="0"/>
-                <a:ea typeface="Calibri" pitchFamily="34" charset="-122"/>
-                <a:cs typeface="Calibri" pitchFamily="34" charset="-120"/>
-              </a:rPr>
-              <a:t>Atlas House. Please bring the file on the November incident: we must be there</a:t>
-            </a:r>
-            <a:endParaRPr lang="en-US" sz="2100" dirty="0"/>
+              <a:rPr lang="en-US" sz="1800" dirty="0">
+                <a:solidFill>
+                  <a:srgbClr val="2B2F38"/>
+                </a:solidFill>
+                <a:latin typeface="Calibri" pitchFamily="34" charset="0"/>
+                <a:ea typeface="Calibri" pitchFamily="34" charset="-122"/>
+                <a:cs typeface="Calibri" pitchFamily="34" charset="-120"/>
+              </a:rPr>
+              <a:t>the file on the November incident to Atlas House</a:t>
+            </a:r>
+            <a:endParaRPr lang="en-US" sz="1800" dirty="0"/>
           </a:p>
         </p:txBody>
       </p:sp>
@@ -19613,12 +19613,12 @@
         </p:nvSpPr>
         <p:spPr>
           <a:xfrm>
-            <a:off x="10503941" y="3611575"/>
-            <a:ext cx="898208" cy="325374"/>
+            <a:off x="6448806" y="3610051"/>
+            <a:ext cx="782955" cy="278892"/>
           </a:xfrm>
           <a:prstGeom prst="roundRect">
             <a:avLst>
-              <a:gd name="adj" fmla="val 14052"/>
+              <a:gd name="adj" fmla="val 16393"/>
             </a:avLst>
           </a:prstGeom>
           <a:solidFill>
@@ -19642,8 +19642,8 @@
         </p:nvSpPr>
         <p:spPr>
           <a:xfrm>
-            <a:off x="10503941" y="3600907"/>
-            <a:ext cx="898208" cy="346710"/>
+            <a:off x="6448806" y="3600907"/>
+            <a:ext cx="782955" cy="297180"/>
           </a:xfrm>
           <a:prstGeom prst="rect">
             <a:avLst/>
@@ -19659,7 +19659,7 @@
               <a:buNone/>
             </a:pPr>
             <a:r>
-              <a:rPr lang="en-US" sz="2100" b="1" dirty="0">
+              <a:rPr lang="en-US" sz="1800" b="1" dirty="0">
                 <a:solidFill>
                   <a:srgbClr val="2B2F38"/>
                 </a:solidFill>
@@ -19669,7 +19669,7 @@
               </a:rPr>
               <a:t>by 8.15</a:t>
             </a:r>
-            <a:endParaRPr lang="en-US" sz="2100" dirty="0"/>
+            <a:endParaRPr lang="en-US" sz="1800" dirty="0"/>
           </a:p>
         </p:txBody>
       </p:sp>
@@ -19681,8 +19681,8 @@
         </p:nvSpPr>
         <p:spPr>
           <a:xfrm>
-            <a:off x="11402149" y="3600907"/>
-            <a:ext cx="250088" cy="346710"/>
+            <a:off x="7231761" y="3600907"/>
+            <a:ext cx="240487" cy="297180"/>
           </a:xfrm>
           <a:prstGeom prst="rect">
             <a:avLst/>
@@ -19698,7 +19698,7 @@
               <a:buNone/>
             </a:pPr>
             <a:r>
-              <a:rPr lang="en-US" sz="2100" dirty="0">
+              <a:rPr lang="en-US" sz="1800" dirty="0">
                 <a:solidFill>
                   <a:srgbClr val="2B2F38"/>
                 </a:solidFill>
@@ -19708,7 +19708,7 @@
               </a:rPr>
               <a:t>.</a:t>
             </a:r>
-            <a:endParaRPr lang="en-US" sz="2100" dirty="0"/>
+            <a:endParaRPr lang="en-US" sz="1800" dirty="0"/>
           </a:p>
         </p:txBody>
       </p:sp>
@@ -19720,8 +19720,8 @@
         </p:nvSpPr>
         <p:spPr>
           <a:xfrm>
-            <a:off x="10953045" y="3536899"/>
-            <a:ext cx="914" cy="74676"/>
+            <a:off x="6840284" y="3536899"/>
+            <a:ext cx="914" cy="73152"/>
           </a:xfrm>
           <a:prstGeom prst="line">
             <a:avLst/>
@@ -19743,7 +19743,7 @@
         </p:nvSpPr>
         <p:spPr>
           <a:xfrm>
-            <a:off x="10408710" y="3290011"/>
+            <a:off x="6295949" y="3290011"/>
             <a:ext cx="1088669" cy="246888"/>
           </a:xfrm>
           <a:prstGeom prst="roundRect">
@@ -19772,7 +19772,7 @@
         </p:nvSpPr>
         <p:spPr>
           <a:xfrm>
-            <a:off x="10408710" y="3290011"/>
+            <a:off x="6295949" y="3290011"/>
             <a:ext cx="1088669" cy="246888"/>
           </a:xfrm>
           <a:prstGeom prst="rect">
@@ -19811,8 +19811,8 @@
         </p:nvSpPr>
         <p:spPr>
           <a:xfrm>
-            <a:off x="3966381" y="4605985"/>
-            <a:ext cx="1460144" cy="346710"/>
+            <a:off x="3843909" y="4556455"/>
+            <a:ext cx="856107" cy="297180"/>
           </a:xfrm>
           <a:prstGeom prst="rect">
             <a:avLst/>
@@ -19828,17 +19828,17 @@
               <a:buNone/>
             </a:pPr>
             <a:r>
-              <a:rPr lang="en-US" sz="2100" dirty="0">
-                <a:solidFill>
-                  <a:srgbClr val="2B2F38"/>
-                </a:solidFill>
-                <a:latin typeface="Calibri" pitchFamily="34" charset="0"/>
-                <a:ea typeface="Calibri" pitchFamily="34" charset="-122"/>
-                <a:cs typeface="Calibri" pitchFamily="34" charset="-120"/>
-              </a:rPr>
-              <a:t>And sorry, I</a:t>
-            </a:r>
-            <a:endParaRPr lang="en-US" sz="2100" dirty="0"/>
+              <a:rPr lang="en-US" sz="1800" dirty="0">
+                <a:solidFill>
+                  <a:srgbClr val="2B2F38"/>
+                </a:solidFill>
+                <a:latin typeface="Calibri" pitchFamily="34" charset="0"/>
+                <a:ea typeface="Calibri" pitchFamily="34" charset="-122"/>
+                <a:cs typeface="Calibri" pitchFamily="34" charset="-120"/>
+              </a:rPr>
+              <a:t>Sorry, I</a:t>
+            </a:r>
+            <a:endParaRPr lang="en-US" sz="1800" dirty="0"/>
           </a:p>
         </p:txBody>
       </p:sp>
@@ -19850,12 +19850,12 @@
         </p:nvSpPr>
         <p:spPr>
           <a:xfrm>
-            <a:off x="5322208" y="4616653"/>
-            <a:ext cx="1312126" cy="325374"/>
+            <a:off x="4587088" y="4565599"/>
+            <a:ext cx="1137742" cy="278892"/>
           </a:xfrm>
           <a:prstGeom prst="roundRect">
             <a:avLst>
-              <a:gd name="adj" fmla="val 14052"/>
+              <a:gd name="adj" fmla="val 16393"/>
             </a:avLst>
           </a:prstGeom>
           <a:solidFill>
@@ -19879,8 +19879,8 @@
         </p:nvSpPr>
         <p:spPr>
           <a:xfrm>
-            <a:off x="5322208" y="4605985"/>
-            <a:ext cx="1312126" cy="346710"/>
+            <a:off x="4587088" y="4556455"/>
+            <a:ext cx="1137742" cy="297180"/>
           </a:xfrm>
           <a:prstGeom prst="rect">
             <a:avLst/>
@@ -19896,7 +19896,7 @@
               <a:buNone/>
             </a:pPr>
             <a:r>
-              <a:rPr lang="en-US" sz="2100" b="1" dirty="0">
+              <a:rPr lang="en-US" sz="1800" b="1" dirty="0">
                 <a:solidFill>
                   <a:srgbClr val="2B2F38"/>
                 </a:solidFill>
@@ -19906,7 +19906,7 @@
               </a:rPr>
               <a:t>didn’t hear</a:t>
             </a:r>
-            <a:endParaRPr lang="en-US" sz="2100" dirty="0"/>
+            <a:endParaRPr lang="en-US" sz="1800" dirty="0"/>
           </a:p>
         </p:txBody>
       </p:sp>
@@ -19918,8 +19918,8 @@
         </p:nvSpPr>
         <p:spPr>
           <a:xfrm>
-            <a:off x="6712896" y="4605985"/>
-            <a:ext cx="2899562" cy="346710"/>
+            <a:off x="5794781" y="4556455"/>
+            <a:ext cx="3940150" cy="297180"/>
           </a:xfrm>
           <a:prstGeom prst="rect">
             <a:avLst/>
@@ -19935,17 +19935,17 @@
               <a:buNone/>
             </a:pPr>
             <a:r>
-              <a:rPr lang="en-US" sz="2100" dirty="0">
-                <a:solidFill>
-                  <a:srgbClr val="2B2F38"/>
-                </a:solidFill>
-                <a:latin typeface="Calibri" pitchFamily="34" charset="0"/>
-                <a:ea typeface="Calibri" pitchFamily="34" charset="-122"/>
-                <a:cs typeface="Calibri" pitchFamily="34" charset="-120"/>
-              </a:rPr>
-              <a:t>my phone the first time!</a:t>
-            </a:r>
-            <a:endParaRPr lang="en-US" sz="2100" dirty="0"/>
+              <a:rPr lang="en-US" sz="1800" dirty="0">
+                <a:solidFill>
+                  <a:srgbClr val="2B2F38"/>
+                </a:solidFill>
+                <a:latin typeface="Calibri" pitchFamily="34" charset="0"/>
+                <a:ea typeface="Calibri" pitchFamily="34" charset="-122"/>
+                <a:cs typeface="Calibri" pitchFamily="34" charset="-120"/>
+              </a:rPr>
+              <a:t>my phone at 6.58: I was in the shower!</a:t>
+            </a:r>
+            <a:endParaRPr lang="en-US" sz="1800" dirty="0"/>
           </a:p>
         </p:txBody>
       </p:sp>
@@ -19957,8 +19957,8 @@
         </p:nvSpPr>
         <p:spPr>
           <a:xfrm>
-            <a:off x="5978271" y="4541977"/>
-            <a:ext cx="914" cy="74676"/>
+            <a:off x="5155959" y="4492447"/>
+            <a:ext cx="914" cy="73152"/>
           </a:xfrm>
           <a:prstGeom prst="line">
             <a:avLst/>
@@ -19980,7 +19980,7 @@
         </p:nvSpPr>
         <p:spPr>
           <a:xfrm>
-            <a:off x="5448256" y="4295089"/>
+            <a:off x="4625943" y="4245559"/>
             <a:ext cx="1060031" cy="246888"/>
           </a:xfrm>
           <a:prstGeom prst="roundRect">
@@ -20009,7 +20009,7 @@
         </p:nvSpPr>
         <p:spPr>
           <a:xfrm>
-            <a:off x="5448256" y="4295089"/>
+            <a:off x="4625943" y="4245559"/>
             <a:ext cx="1060031" cy="246888"/>
           </a:xfrm>
           <a:prstGeom prst="rect">
@@ -20048,12 +20048,12 @@
         </p:nvSpPr>
         <p:spPr>
           <a:xfrm>
-            <a:off x="1508760" y="5437327"/>
-            <a:ext cx="10332720" cy="877062"/>
+            <a:off x="1508760" y="5338267"/>
+            <a:ext cx="10332720" cy="827532"/>
           </a:xfrm>
           <a:prstGeom prst="roundRect">
             <a:avLst>
-              <a:gd name="adj" fmla="val 8341"/>
+              <a:gd name="adj" fmla="val 8840"/>
             </a:avLst>
           </a:prstGeom>
           <a:solidFill>
@@ -20075,7 +20075,7 @@
         </p:nvSpPr>
         <p:spPr>
           <a:xfrm>
-            <a:off x="1645920" y="5281879"/>
+            <a:off x="1645920" y="5182819"/>
             <a:ext cx="2200224" cy="274320"/>
           </a:xfrm>
           <a:prstGeom prst="roundRect">
@@ -20104,7 +20104,7 @@
         </p:nvSpPr>
         <p:spPr>
           <a:xfrm>
-            <a:off x="1645920" y="5281879"/>
+            <a:off x="1645920" y="5182819"/>
             <a:ext cx="2200224" cy="274320"/>
           </a:xfrm>
           <a:prstGeom prst="rect">
@@ -20143,12 +20143,12 @@
         </p:nvSpPr>
         <p:spPr>
           <a:xfrm>
-            <a:off x="1691640" y="5896051"/>
-            <a:ext cx="2205838" cy="325374"/>
+            <a:off x="1691640" y="5795467"/>
+            <a:ext cx="1903781" cy="278892"/>
           </a:xfrm>
           <a:prstGeom prst="roundRect">
             <a:avLst>
-              <a:gd name="adj" fmla="val 14052"/>
+              <a:gd name="adj" fmla="val 16393"/>
             </a:avLst>
           </a:prstGeom>
           <a:solidFill>
@@ -20172,8 +20172,8 @@
         </p:nvSpPr>
         <p:spPr>
           <a:xfrm>
-            <a:off x="1691640" y="5885383"/>
-            <a:ext cx="2205838" cy="346710"/>
+            <a:off x="1691640" y="5786323"/>
+            <a:ext cx="1903781" cy="297180"/>
           </a:xfrm>
           <a:prstGeom prst="rect">
             <a:avLst/>
@@ -20189,7 +20189,7 @@
               <a:buNone/>
             </a:pPr>
             <a:r>
-              <a:rPr lang="en-US" sz="2100" b="1" dirty="0">
+              <a:rPr lang="en-US" sz="1800" b="1" dirty="0">
                 <a:solidFill>
                   <a:srgbClr val="2B2F38"/>
                 </a:solidFill>
@@ -20199,7 +20199,7 @@
               </a:rPr>
               <a:t>We don’t know yet</a:t>
             </a:r>
-            <a:endParaRPr lang="en-US" sz="2100" dirty="0"/>
+            <a:endParaRPr lang="en-US" sz="1800" dirty="0"/>
           </a:p>
         </p:txBody>
       </p:sp>
@@ -20211,8 +20211,8 @@
         </p:nvSpPr>
         <p:spPr>
           <a:xfrm>
-            <a:off x="3976040" y="5885383"/>
-            <a:ext cx="4418190" cy="346710"/>
+            <a:off x="3665372" y="5786323"/>
+            <a:ext cx="4211269" cy="297180"/>
           </a:xfrm>
           <a:prstGeom prst="rect">
             <a:avLst/>
@@ -20228,17 +20228,17 @@
               <a:buNone/>
             </a:pPr>
             <a:r>
-              <a:rPr lang="en-US" sz="2100" dirty="0">
-                <a:solidFill>
-                  <a:srgbClr val="2B2F38"/>
-                </a:solidFill>
-                <a:latin typeface="Calibri" pitchFamily="34" charset="0"/>
-                <a:ea typeface="Calibri" pitchFamily="34" charset="-122"/>
-                <a:cs typeface="Calibri" pitchFamily="34" charset="-120"/>
-              </a:rPr>
-              <a:t>how long the water has been running:</a:t>
-            </a:r>
-            <a:endParaRPr lang="en-US" sz="2100" dirty="0"/>
+              <a:rPr lang="en-US" sz="1800" dirty="0">
+                <a:solidFill>
+                  <a:srgbClr val="2B2F38"/>
+                </a:solidFill>
+                <a:latin typeface="Calibri" pitchFamily="34" charset="0"/>
+                <a:ea typeface="Calibri" pitchFamily="34" charset="-122"/>
+                <a:cs typeface="Calibri" pitchFamily="34" charset="-120"/>
+              </a:rPr>
+              <a:t>how long the water has been running, but</a:t>
+            </a:r>
+            <a:endParaRPr lang="en-US" sz="1800" dirty="0"/>
           </a:p>
         </p:txBody>
       </p:sp>
@@ -20250,12 +20250,12 @@
         </p:nvSpPr>
         <p:spPr>
           <a:xfrm>
-            <a:off x="8289912" y="5896051"/>
-            <a:ext cx="1558023" cy="325374"/>
+            <a:off x="7763713" y="5795467"/>
+            <a:ext cx="1348511" cy="278892"/>
           </a:xfrm>
           <a:prstGeom prst="roundRect">
             <a:avLst>
-              <a:gd name="adj" fmla="val 14052"/>
+              <a:gd name="adj" fmla="val 16393"/>
             </a:avLst>
           </a:prstGeom>
           <a:solidFill>
@@ -20279,8 +20279,8 @@
         </p:nvSpPr>
         <p:spPr>
           <a:xfrm>
-            <a:off x="8289912" y="5885383"/>
-            <a:ext cx="1558023" cy="346710"/>
+            <a:off x="7763713" y="5786323"/>
+            <a:ext cx="1348511" cy="297180"/>
           </a:xfrm>
           <a:prstGeom prst="rect">
             <a:avLst/>
@@ -20296,7 +20296,7 @@
               <a:buNone/>
             </a:pPr>
             <a:r>
-              <a:rPr lang="en-US" sz="2100" b="1" dirty="0">
+              <a:rPr lang="en-US" sz="1800" b="1" dirty="0">
                 <a:solidFill>
                   <a:srgbClr val="2B2F38"/>
                 </a:solidFill>
@@ -20306,7 +20306,7 @@
               </a:rPr>
               <a:t>the alarm log</a:t>
             </a:r>
-            <a:endParaRPr lang="en-US" sz="2100" dirty="0"/>
+            <a:endParaRPr lang="en-US" sz="1800" dirty="0"/>
           </a:p>
         </p:txBody>
       </p:sp>
@@ -20318,8 +20318,8 @@
         </p:nvSpPr>
         <p:spPr>
           <a:xfrm>
-            <a:off x="9926498" y="5885383"/>
-            <a:ext cx="1508150" cy="346710"/>
+            <a:off x="9182176" y="5786323"/>
+            <a:ext cx="2646959" cy="297180"/>
           </a:xfrm>
           <a:prstGeom prst="rect">
             <a:avLst/>
@@ -20335,17 +20335,17 @@
               <a:buNone/>
             </a:pPr>
             <a:r>
-              <a:rPr lang="en-US" sz="2100" dirty="0">
-                <a:solidFill>
-                  <a:srgbClr val="2B2F38"/>
-                </a:solidFill>
-                <a:latin typeface="Calibri" pitchFamily="34" charset="0"/>
-                <a:ea typeface="Calibri" pitchFamily="34" charset="-122"/>
-                <a:cs typeface="Calibri" pitchFamily="34" charset="-120"/>
-              </a:rPr>
-              <a:t>will show it.</a:t>
-            </a:r>
-            <a:endParaRPr lang="en-US" sz="2100" dirty="0"/>
+              <a:rPr lang="en-US" sz="1800" dirty="0">
+                <a:solidFill>
+                  <a:srgbClr val="2B2F38"/>
+                </a:solidFill>
+                <a:latin typeface="Calibri" pitchFamily="34" charset="0"/>
+                <a:ea typeface="Calibri" pitchFamily="34" charset="-122"/>
+                <a:cs typeface="Calibri" pitchFamily="34" charset="-120"/>
+              </a:rPr>
+              <a:t>will show when it started.</a:t>
+            </a:r>
+            <a:endParaRPr lang="en-US" sz="1800" dirty="0"/>
           </a:p>
         </p:txBody>
       </p:sp>
@@ -20357,8 +20357,8 @@
         </p:nvSpPr>
         <p:spPr>
           <a:xfrm>
-            <a:off x="2794559" y="5821375"/>
-            <a:ext cx="914" cy="74676"/>
+            <a:off x="2643530" y="5722315"/>
+            <a:ext cx="914" cy="73152"/>
           </a:xfrm>
           <a:prstGeom prst="line">
             <a:avLst/>
@@ -20380,7 +20380,7 @@
         </p:nvSpPr>
         <p:spPr>
           <a:xfrm>
-            <a:off x="2163680" y="5574487"/>
+            <a:off x="2012652" y="5475427"/>
             <a:ext cx="1261758" cy="246888"/>
           </a:xfrm>
           <a:prstGeom prst="roundRect">
@@ -20409,7 +20409,7 @@
         </p:nvSpPr>
         <p:spPr>
           <a:xfrm>
-            <a:off x="2163680" y="5574487"/>
+            <a:off x="2012652" y="5475427"/>
             <a:ext cx="1261758" cy="246888"/>
           </a:xfrm>
           <a:prstGeom prst="rect">
@@ -20448,8 +20448,8 @@
         </p:nvSpPr>
         <p:spPr>
           <a:xfrm>
-            <a:off x="9068924" y="5821375"/>
-            <a:ext cx="914" cy="74676"/>
+            <a:off x="8437969" y="5722315"/>
+            <a:ext cx="914" cy="73152"/>
           </a:xfrm>
           <a:prstGeom prst="line">
             <a:avLst/>
@@ -20471,7 +20471,7 @@
         </p:nvSpPr>
         <p:spPr>
           <a:xfrm>
-            <a:off x="8756212" y="5574487"/>
+            <a:off x="8125257" y="5475427"/>
             <a:ext cx="625424" cy="246888"/>
           </a:xfrm>
           <a:prstGeom prst="roundRect">
@@ -20500,7 +20500,7 @@
         </p:nvSpPr>
         <p:spPr>
           <a:xfrm>
-            <a:off x="8756212" y="5574487"/>
+            <a:off x="8125257" y="5475427"/>
             <a:ext cx="625424" cy="246888"/>
           </a:xfrm>
           <a:prstGeom prst="rect">
@@ -21443,7 +21443,7 @@
                   <a:srgbClr val="2B2F38"/>
                 </a:solidFill>
               </a:rPr>
-              <a:t>A delay or a duration: </a:t>
+              <a:t>A time from now or a duration: </a:t>
             </a:r>
             <a:r>
               <a:rPr lang="en-US" sz="1450" b="1" dirty="0">

</xml_diff>